<commit_message>
Per-course looks, isiZulu decks, generation prompts and Gemini/Veo media script
- style.md per course: Linocut Garden, Field Notes, Chalk & Kraft, Clay Market,
  Comic Panels (none reuse the student course's watercolour look); palette, fonts,
  recurring characters, image + animation anchors, deck theme
- build.py: decks themed per course; <deck>.zu.pptx from i18n/zu.json; every NEW
  manifest item carries a full prompt; prompts-images.md / prompts-animations.md
  per course for ChatGPT and Google Flow
- scripts/courses/generate-media.py: generate images (Gemini) and clips (Veo) into
  target paths with GEMINI_API_KEY
- i18n/zu.json drafts for four courses (Teach the Teachers in progress)
- PRODUCTION-GUIDE.md replaces the Codex handoff; bilingual poster rules

Co-Authored-By: Claude Opus 5.5 <noreply@anthropic.com>
Claude-Session: https://claude.ai/code/session_01DVvirN1GL3YvgFnXUT6gyq
</commit_message>
<xml_diff>
--- a/courses/build/ai-literacy/A-D1.pptx
+++ b/courses/build/ai-literacy/A-D1.pptx
@@ -5200,7 +5200,7 @@
     <p:bg>
       <p:bgPr>
         <a:solidFill>
-          <a:srgbClr val="F7F2E9"/>
+          <a:srgbClr val="FFFFFF"/>
         </a:solidFill>
         <a:effectLst/>
       </p:bgPr>
@@ -5242,9 +5242,9 @@
             <a:r>
               <a:rPr sz="1000" b="0">
                 <a:solidFill>
-                  <a:srgbClr val="6B6255"/>
-                </a:solidFill>
-                <a:latin typeface="Arial"/>
+                  <a:srgbClr val="111111"/>
+                </a:solidFill>
+                <a:latin typeface="Verdana"/>
               </a:rPr>
               <a:t>A-D1-01   ·   Poster A-P01</a:t>
             </a:r>
@@ -5281,9 +5281,9 @@
             <a:r>
               <a:rPr sz="1000" b="0">
                 <a:solidFill>
-                  <a:srgbClr val="6B6255"/>
-                </a:solidFill>
-                <a:latin typeface="Arial"/>
+                  <a:srgbClr val="111111"/>
+                </a:solidFill>
+                <a:latin typeface="Verdana"/>
               </a:rPr>
               <a:t>AI Literacy</a:t>
             </a:r>
@@ -5320,9 +5320,9 @@
             <a:r>
               <a:rPr sz="3800" b="1">
                 <a:solidFill>
-                  <a:srgbClr val="1F4D2B"/>
-                </a:solidFill>
-                <a:latin typeface="Georgia"/>
+                  <a:srgbClr val="111111"/>
+                </a:solidFill>
+                <a:latin typeface="Impact"/>
               </a:rPr>
               <a:t>Welcome</a:t>
             </a:r>
@@ -5344,7 +5344,7 @@
             <a:avLst/>
           </a:prstGeom>
           <a:solidFill>
-            <a:srgbClr val="E2D8C4"/>
+            <a:srgbClr val="D6336C"/>
           </a:solidFill>
           <a:ln>
             <a:noFill/>
@@ -5403,9 +5403,9 @@
             <a:r>
               <a:rPr sz="2800" b="0">
                 <a:solidFill>
-                  <a:srgbClr val="20190F"/>
-                </a:solidFill>
-                <a:latin typeface="Arial"/>
+                  <a:srgbClr val="111111"/>
+                </a:solidFill>
+                <a:latin typeface="Verdana"/>
               </a:rPr>
               <a:t>•  AI Literacy</a:t>
             </a:r>
@@ -5419,9 +5419,9 @@
             <a:r>
               <a:rPr sz="2800" b="0">
                 <a:solidFill>
-                  <a:srgbClr val="20190F"/>
-                </a:solidFill>
-                <a:latin typeface="Arial"/>
+                  <a:srgbClr val="111111"/>
+                </a:solidFill>
+                <a:latin typeface="Verdana"/>
               </a:rPr>
               <a:t>•  Using AI safely and usefully</a:t>
             </a:r>
@@ -5435,9 +5435,9 @@
             <a:r>
               <a:rPr sz="2800" b="0">
                 <a:solidFill>
-                  <a:srgbClr val="20190F"/>
-                </a:solidFill>
-                <a:latin typeface="Arial"/>
+                  <a:srgbClr val="111111"/>
+                </a:solidFill>
+                <a:latin typeface="Verdana"/>
               </a:rPr>
               <a:t>•  Day 1 of 2</a:t>
             </a:r>
@@ -5459,11 +5459,11 @@
             <a:avLst/>
           </a:prstGeom>
           <a:solidFill>
-            <a:srgbClr val="FBF6EC"/>
+            <a:srgbClr val="FFFFFF"/>
           </a:solidFill>
           <a:ln w="15875">
             <a:solidFill>
-              <a:srgbClr val="E2D8C4"/>
+              <a:srgbClr val="D6336C"/>
             </a:solidFill>
           </a:ln>
           <a:effectLst/>
@@ -5520,9 +5520,9 @@
             <a:r>
               <a:rPr sz="1200" b="1">
                 <a:solidFill>
-                  <a:srgbClr val="C07A1E"/>
-                </a:solidFill>
-                <a:latin typeface="Arial"/>
+                  <a:srgbClr val="1FA3C8"/>
+                </a:solidFill>
+                <a:latin typeface="Verdana"/>
               </a:rPr>
               <a:t>IMAGE · A-IMG-01 · coming</a:t>
             </a:r>
@@ -5559,9 +5559,9 @@
             <a:r>
               <a:rPr sz="1800" b="1">
                 <a:solidFill>
-                  <a:srgbClr val="1F4D2B"/>
-                </a:solidFill>
-                <a:latin typeface="Georgia"/>
+                  <a:srgbClr val="111111"/>
+                </a:solidFill>
+                <a:latin typeface="Impact"/>
               </a:rPr>
               <a:t>Learning together under a tree</a:t>
             </a:r>
@@ -5598,9 +5598,9 @@
             <a:r>
               <a:rPr sz="1100" b="0">
                 <a:solidFill>
-                  <a:srgbClr val="20190F"/>
-                </a:solidFill>
-                <a:latin typeface="Arial"/>
+                  <a:srgbClr val="111111"/>
+                </a:solidFill>
+                <a:latin typeface="Verdana"/>
               </a:rPr>
               <a:t>Landscape 16:9. A group of five learners on plastic chairs under a big shade tree near a small community garden: a gogo, an older man in a hat, two young women, a young man. One phone is shared between the gogo and a young woman; the young woman points at the screen, the gogo laughs. The others lean in. A poster on a fence behind (plain shapes, no text).…</a:t>
             </a:r>
@@ -5621,7 +5621,7 @@
     <p:bg>
       <p:bgPr>
         <a:solidFill>
-          <a:srgbClr val="F7F2E9"/>
+          <a:srgbClr val="FFFFFF"/>
         </a:solidFill>
         <a:effectLst/>
       </p:bgPr>
@@ -5663,9 +5663,9 @@
             <a:r>
               <a:rPr sz="1000" b="0">
                 <a:solidFill>
-                  <a:srgbClr val="6B6255"/>
-                </a:solidFill>
-                <a:latin typeface="Arial"/>
+                  <a:srgbClr val="111111"/>
+                </a:solidFill>
+                <a:latin typeface="Verdana"/>
               </a:rPr>
               <a:t>A-D1-10   ·   Poster A-P04</a:t>
             </a:r>
@@ -5702,9 +5702,9 @@
             <a:r>
               <a:rPr sz="1000" b="0">
                 <a:solidFill>
-                  <a:srgbClr val="6B6255"/>
-                </a:solidFill>
-                <a:latin typeface="Arial"/>
+                  <a:srgbClr val="111111"/>
+                </a:solidFill>
+                <a:latin typeface="Verdana"/>
               </a:rPr>
               <a:t>AI Literacy</a:t>
             </a:r>
@@ -5726,7 +5726,7 @@
             <a:avLst/>
           </a:prstGeom>
           <a:solidFill>
-            <a:srgbClr val="C07A1E"/>
+            <a:srgbClr val="1FA3C8"/>
           </a:solidFill>
           <a:ln>
             <a:noFill/>
@@ -5785,9 +5785,9 @@
             <a:r>
               <a:rPr sz="1400" b="1">
                 <a:solidFill>
-                  <a:srgbClr val="F7F2E9"/>
-                </a:solidFill>
-                <a:latin typeface="Arial"/>
+                  <a:srgbClr val="FFFFFF"/>
+                </a:solidFill>
+                <a:latin typeface="Verdana"/>
               </a:rPr>
               <a:t>YOUR TURN</a:t>
             </a:r>
@@ -5824,9 +5824,9 @@
             <a:r>
               <a:rPr sz="3800" b="1">
                 <a:solidFill>
-                  <a:srgbClr val="1F4D2B"/>
-                </a:solidFill>
-                <a:latin typeface="Georgia"/>
+                  <a:srgbClr val="111111"/>
+                </a:solidFill>
+                <a:latin typeface="Impact"/>
               </a:rPr>
               <a:t>Phone ready</a:t>
             </a:r>
@@ -5848,7 +5848,7 @@
             <a:avLst/>
           </a:prstGeom>
           <a:solidFill>
-            <a:srgbClr val="E2D8C4"/>
+            <a:srgbClr val="D6336C"/>
           </a:solidFill>
           <a:ln>
             <a:noFill/>
@@ -5907,9 +5907,9 @@
             <a:r>
               <a:rPr sz="2600" b="1">
                 <a:solidFill>
-                  <a:srgbClr val="20190F"/>
-                </a:solidFill>
-                <a:latin typeface="Arial"/>
+                  <a:srgbClr val="111111"/>
+                </a:solidFill>
+                <a:latin typeface="Verdana"/>
               </a:rPr>
               <a:t>•  Every phone: 4 settings, 15 minutes</a:t>
             </a:r>
@@ -5923,9 +5923,9 @@
             <a:r>
               <a:rPr sz="2600" b="1">
                 <a:solidFill>
-                  <a:srgbClr val="20190F"/>
-                </a:solidFill>
-                <a:latin typeface="Arial"/>
+                  <a:srgbClr val="111111"/>
+                </a:solidFill>
+                <a:latin typeface="Verdana"/>
               </a:rPr>
               <a:t>•  You tap, the group reads</a:t>
             </a:r>
@@ -5939,9 +5939,9 @@
             <a:r>
               <a:rPr sz="2600" b="1">
                 <a:solidFill>
-                  <a:srgbClr val="20190F"/>
-                </a:solidFill>
-                <a:latin typeface="Arial"/>
+                  <a:srgbClr val="111111"/>
+                </a:solidFill>
+                <a:latin typeface="Verdana"/>
               </a:rPr>
               <a:t>•  Stuck? Help Desk at lunch</a:t>
             </a:r>
@@ -5963,11 +5963,11 @@
             <a:avLst/>
           </a:prstGeom>
           <a:solidFill>
-            <a:srgbClr val="FBF6EC"/>
+            <a:srgbClr val="FFFFFF"/>
           </a:solidFill>
           <a:ln w="15875">
             <a:solidFill>
-              <a:srgbClr val="E2D8C4"/>
+              <a:srgbClr val="D6336C"/>
             </a:solidFill>
           </a:ln>
           <a:effectLst/>
@@ -6024,9 +6024,9 @@
             <a:r>
               <a:rPr sz="1200" b="1">
                 <a:solidFill>
-                  <a:srgbClr val="C07A1E"/>
-                </a:solidFill>
-                <a:latin typeface="Arial"/>
+                  <a:srgbClr val="1FA3C8"/>
+                </a:solidFill>
+                <a:latin typeface="Verdana"/>
               </a:rPr>
               <a:t>POSTER ART · A-P04-ART · coming</a:t>
             </a:r>
@@ -6063,9 +6063,9 @@
             <a:r>
               <a:rPr sz="1800" b="1">
                 <a:solidFill>
-                  <a:srgbClr val="1F4D2B"/>
-                </a:solidFill>
-                <a:latin typeface="Georgia"/>
+                  <a:srgbClr val="111111"/>
+                </a:solidFill>
+                <a:latin typeface="Impact"/>
               </a:rPr>
               <a:t>Artwork for A-P04 · Save your data</a:t>
             </a:r>
@@ -6102,9 +6102,9 @@
             <a:r>
               <a:rPr sz="1100" b="0">
                 <a:solidFill>
-                  <a:srgbClr val="20190F"/>
-                </a:solidFill>
-                <a:latin typeface="Arial"/>
+                  <a:srgbClr val="111111"/>
+                </a:solidFill>
+                <a:latin typeface="Verdana"/>
               </a:rPr>
               <a:t>A phone drawn as a clay water pot (a data "pot") with a small tap at the bottom; a few drops fall from it. Around it: ① a photo/video icon with a pause symbol (auto-download off), ② a small photo next to a big photo, the small one ticked (standard quality), ③ a gauge/dial turned to low (data saver), ④ a Wi-Fi fan-shape over a download arrow (updates on…</a:t>
             </a:r>
@@ -6125,7 +6125,7 @@
     <p:bg>
       <p:bgPr>
         <a:solidFill>
-          <a:srgbClr val="F7F2E9"/>
+          <a:srgbClr val="FFFFFF"/>
         </a:solidFill>
         <a:effectLst/>
       </p:bgPr>
@@ -6167,9 +6167,9 @@
             <a:r>
               <a:rPr sz="1000" b="0">
                 <a:solidFill>
-                  <a:srgbClr val="6B6255"/>
-                </a:solidFill>
-                <a:latin typeface="Arial"/>
+                  <a:srgbClr val="111111"/>
+                </a:solidFill>
+                <a:latin typeface="Verdana"/>
               </a:rPr>
               <a:t>A-D1-11   ·   Poster A-P05</a:t>
             </a:r>
@@ -6206,9 +6206,9 @@
             <a:r>
               <a:rPr sz="1000" b="0">
                 <a:solidFill>
-                  <a:srgbClr val="6B6255"/>
-                </a:solidFill>
-                <a:latin typeface="Arial"/>
+                  <a:srgbClr val="111111"/>
+                </a:solidFill>
+                <a:latin typeface="Verdana"/>
               </a:rPr>
               <a:t>AI Literacy</a:t>
             </a:r>
@@ -6245,9 +6245,9 @@
             <a:r>
               <a:rPr sz="3800" b="1">
                 <a:solidFill>
-                  <a:srgbClr val="1F4D2B"/>
-                </a:solidFill>
-                <a:latin typeface="Georgia"/>
+                  <a:srgbClr val="111111"/>
+                </a:solidFill>
+                <a:latin typeface="Impact"/>
               </a:rPr>
               <a:t>Ask with your whole hand</a:t>
             </a:r>
@@ -6269,7 +6269,7 @@
             <a:avLst/>
           </a:prstGeom>
           <a:solidFill>
-            <a:srgbClr val="E2D8C4"/>
+            <a:srgbClr val="D6336C"/>
           </a:solidFill>
           <a:ln>
             <a:noFill/>
@@ -6328,9 +6328,9 @@
             <a:r>
               <a:rPr sz="2800" b="0">
                 <a:solidFill>
-                  <a:srgbClr val="20190F"/>
-                </a:solidFill>
-                <a:latin typeface="Arial"/>
+                  <a:srgbClr val="111111"/>
+                </a:solidFill>
+                <a:latin typeface="Verdana"/>
               </a:rPr>
               <a:t>•  Who I am · What I have</a:t>
             </a:r>
@@ -6344,9 +6344,9 @@
             <a:r>
               <a:rPr sz="2800" b="0">
                 <a:solidFill>
-                  <a:srgbClr val="20190F"/>
-                </a:solidFill>
-                <a:latin typeface="Arial"/>
+                  <a:srgbClr val="111111"/>
+                </a:solidFill>
+                <a:latin typeface="Verdana"/>
               </a:rPr>
               <a:t>•  What I want · How to answer</a:t>
             </a:r>
@@ -6360,9 +6360,9 @@
             <a:r>
               <a:rPr sz="2800" b="0">
                 <a:solidFill>
-                  <a:srgbClr val="20190F"/>
-                </a:solidFill>
-                <a:latin typeface="Arial"/>
+                  <a:srgbClr val="111111"/>
+                </a:solidFill>
+                <a:latin typeface="Verdana"/>
               </a:rPr>
               <a:t>•  Ask again</a:t>
             </a:r>
@@ -6384,11 +6384,11 @@
             <a:avLst/>
           </a:prstGeom>
           <a:solidFill>
-            <a:srgbClr val="FBF6EC"/>
+            <a:srgbClr val="FFFFFF"/>
           </a:solidFill>
           <a:ln w="15875">
             <a:solidFill>
-              <a:srgbClr val="E2D8C4"/>
+              <a:srgbClr val="D6336C"/>
             </a:solidFill>
           </a:ln>
           <a:effectLst/>
@@ -6445,9 +6445,9 @@
             <a:r>
               <a:rPr sz="1200" b="1">
                 <a:solidFill>
-                  <a:srgbClr val="C07A1E"/>
-                </a:solidFill>
-                <a:latin typeface="Arial"/>
+                  <a:srgbClr val="1FA3C8"/>
+                </a:solidFill>
+                <a:latin typeface="Verdana"/>
               </a:rPr>
               <a:t>POSTER ART · A-P05-ART · coming</a:t>
             </a:r>
@@ -6484,9 +6484,9 @@
             <a:r>
               <a:rPr sz="1800" b="1">
                 <a:solidFill>
-                  <a:srgbClr val="1F4D2B"/>
-                </a:solidFill>
-                <a:latin typeface="Georgia"/>
+                  <a:srgbClr val="111111"/>
+                </a:solidFill>
+                <a:latin typeface="Impact"/>
               </a:rPr>
               <a:t>Artwork for A-P05 · The Question Hand</a:t>
             </a:r>
@@ -6523,9 +6523,9 @@
             <a:r>
               <a:rPr sz="1100" b="0">
                 <a:solidFill>
-                  <a:srgbClr val="20190F"/>
-                </a:solidFill>
-                <a:latin typeface="Arial"/>
+                  <a:srgbClr val="111111"/>
+                </a:solidFill>
+                <a:latin typeface="Verdana"/>
               </a:rPr>
               <a:t>One big open right hand, palm facing the viewer, brown skin, a farm- worker's hand (a little soil on the fingertips). Beside each finger a small picture: thumb — a simple farmer figure pointing at herself (who I am); pointer — a bed with plants and a water drum (what I have); middle — a target with a seedling in the centre (what I want); ring — three…</a:t>
             </a:r>
@@ -6546,7 +6546,7 @@
     <p:bg>
       <p:bgPr>
         <a:solidFill>
-          <a:srgbClr val="F7F2E9"/>
+          <a:srgbClr val="FFFFFF"/>
         </a:solidFill>
         <a:effectLst/>
       </p:bgPr>
@@ -6588,9 +6588,9 @@
             <a:r>
               <a:rPr sz="1000" b="0">
                 <a:solidFill>
-                  <a:srgbClr val="6B6255"/>
-                </a:solidFill>
-                <a:latin typeface="Arial"/>
+                  <a:srgbClr val="111111"/>
+                </a:solidFill>
+                <a:latin typeface="Verdana"/>
               </a:rPr>
               <a:t>A-D1-12   ·   Poster A-P05</a:t>
             </a:r>
@@ -6627,9 +6627,9 @@
             <a:r>
               <a:rPr sz="1000" b="0">
                 <a:solidFill>
-                  <a:srgbClr val="6B6255"/>
-                </a:solidFill>
-                <a:latin typeface="Arial"/>
+                  <a:srgbClr val="111111"/>
+                </a:solidFill>
+                <a:latin typeface="Verdana"/>
               </a:rPr>
               <a:t>AI Literacy</a:t>
             </a:r>
@@ -6666,9 +6666,9 @@
             <a:r>
               <a:rPr sz="3800" b="1">
                 <a:solidFill>
-                  <a:srgbClr val="1F4D2B"/>
-                </a:solidFill>
-                <a:latin typeface="Georgia"/>
+                  <a:srgbClr val="111111"/>
+                </a:solidFill>
+                <a:latin typeface="Impact"/>
               </a:rPr>
               <a:t>One word or five fingers?</a:t>
             </a:r>
@@ -6690,7 +6690,7 @@
             <a:avLst/>
           </a:prstGeom>
           <a:solidFill>
-            <a:srgbClr val="E2D8C4"/>
+            <a:srgbClr val="D6336C"/>
           </a:solidFill>
           <a:ln>
             <a:noFill/>
@@ -6749,9 +6749,9 @@
             <a:r>
               <a:rPr sz="2400" b="0">
                 <a:solidFill>
-                  <a:srgbClr val="20190F"/>
-                </a:solidFill>
-                <a:latin typeface="Arial"/>
+                  <a:srgbClr val="111111"/>
+                </a:solidFill>
+                <a:latin typeface="Verdana"/>
               </a:rPr>
               <a:t>•  "Spinach?" → a long, useless answer</a:t>
             </a:r>
@@ -6765,9 +6765,9 @@
             <a:r>
               <a:rPr sz="2400" b="0">
                 <a:solidFill>
-                  <a:srgbClr val="20190F"/>
-                </a:solidFill>
-                <a:latin typeface="Arial"/>
+                  <a:srgbClr val="111111"/>
+                </a:solidFill>
+                <a:latin typeface="Verdana"/>
               </a:rPr>
               <a:t>•  Five fingers → 3 useful steps</a:t>
             </a:r>
@@ -6789,11 +6789,11 @@
             <a:avLst/>
           </a:prstGeom>
           <a:solidFill>
-            <a:srgbClr val="FBF6EC"/>
+            <a:srgbClr val="FFFFFF"/>
           </a:solidFill>
           <a:ln w="15875">
             <a:solidFill>
-              <a:srgbClr val="E2D8C4"/>
+              <a:srgbClr val="D6336C"/>
             </a:solidFill>
           </a:ln>
           <a:effectLst/>
@@ -6850,9 +6850,9 @@
             <a:r>
               <a:rPr sz="1200" b="1">
                 <a:solidFill>
-                  <a:srgbClr val="C07A1E"/>
-                </a:solidFill>
-                <a:latin typeface="Arial"/>
+                  <a:srgbClr val="1FA3C8"/>
+                </a:solidFill>
+                <a:latin typeface="Verdana"/>
               </a:rPr>
               <a:t>POSTER ART · A-P05-ART · coming</a:t>
             </a:r>
@@ -6889,9 +6889,9 @@
             <a:r>
               <a:rPr sz="1800" b="1">
                 <a:solidFill>
-                  <a:srgbClr val="1F4D2B"/>
-                </a:solidFill>
-                <a:latin typeface="Georgia"/>
+                  <a:srgbClr val="111111"/>
+                </a:solidFill>
+                <a:latin typeface="Impact"/>
               </a:rPr>
               <a:t>Artwork for A-P05 · The Question Hand</a:t>
             </a:r>
@@ -6928,9 +6928,9 @@
             <a:r>
               <a:rPr sz="1100" b="0">
                 <a:solidFill>
-                  <a:srgbClr val="20190F"/>
-                </a:solidFill>
-                <a:latin typeface="Arial"/>
+                  <a:srgbClr val="111111"/>
+                </a:solidFill>
+                <a:latin typeface="Verdana"/>
               </a:rPr>
               <a:t>One big open right hand, palm facing the viewer, brown skin, a farm- worker's hand (a little soil on the fingertips). Beside each finger a small picture: thumb — a simple farmer figure pointing at herself (who I am); pointer — a bed with plants and a water drum (what I have); middle — a target with a seedling in the centre (what I want); ring — three…</a:t>
             </a:r>
@@ -6951,7 +6951,7 @@
     <p:bg>
       <p:bgPr>
         <a:solidFill>
-          <a:srgbClr val="F7F2E9"/>
+          <a:srgbClr val="FFFFFF"/>
         </a:solidFill>
         <a:effectLst/>
       </p:bgPr>
@@ -6993,9 +6993,9 @@
             <a:r>
               <a:rPr sz="1000" b="0">
                 <a:solidFill>
-                  <a:srgbClr val="6B6255"/>
-                </a:solidFill>
-                <a:latin typeface="Arial"/>
+                  <a:srgbClr val="111111"/>
+                </a:solidFill>
+                <a:latin typeface="Verdana"/>
               </a:rPr>
               <a:t>A-D1-13   ·   Poster A-P05</a:t>
             </a:r>
@@ -7032,9 +7032,9 @@
             <a:r>
               <a:rPr sz="1000" b="0">
                 <a:solidFill>
-                  <a:srgbClr val="6B6255"/>
-                </a:solidFill>
-                <a:latin typeface="Arial"/>
+                  <a:srgbClr val="111111"/>
+                </a:solidFill>
+                <a:latin typeface="Verdana"/>
               </a:rPr>
               <a:t>AI Literacy</a:t>
             </a:r>
@@ -7056,7 +7056,7 @@
             <a:avLst/>
           </a:prstGeom>
           <a:solidFill>
-            <a:srgbClr val="C07A1E"/>
+            <a:srgbClr val="1FA3C8"/>
           </a:solidFill>
           <a:ln>
             <a:noFill/>
@@ -7115,9 +7115,9 @@
             <a:r>
               <a:rPr sz="1400" b="1">
                 <a:solidFill>
-                  <a:srgbClr val="F7F2E9"/>
-                </a:solidFill>
-                <a:latin typeface="Arial"/>
+                  <a:srgbClr val="FFFFFF"/>
+                </a:solidFill>
+                <a:latin typeface="Verdana"/>
               </a:rPr>
               <a:t>YOUR TURN</a:t>
             </a:r>
@@ -7154,9 +7154,9 @@
             <a:r>
               <a:rPr sz="3800" b="1">
                 <a:solidFill>
-                  <a:srgbClr val="1F4D2B"/>
-                </a:solidFill>
-                <a:latin typeface="Georgia"/>
+                  <a:srgbClr val="111111"/>
+                </a:solidFill>
+                <a:latin typeface="Impact"/>
               </a:rPr>
               <a:t>Ask a farm question</a:t>
             </a:r>
@@ -7178,7 +7178,7 @@
             <a:avLst/>
           </a:prstGeom>
           <a:solidFill>
-            <a:srgbClr val="E2D8C4"/>
+            <a:srgbClr val="D6336C"/>
           </a:solidFill>
           <a:ln>
             <a:noFill/>
@@ -7237,9 +7237,9 @@
             <a:r>
               <a:rPr sz="2600" b="1">
                 <a:solidFill>
-                  <a:srgbClr val="20190F"/>
-                </a:solidFill>
-                <a:latin typeface="Arial"/>
+                  <a:srgbClr val="111111"/>
+                </a:solidFill>
+                <a:latin typeface="Verdana"/>
               </a:rPr>
               <a:t>•  4 prompt cards per group</a:t>
             </a:r>
@@ -7253,9 +7253,9 @@
             <a:r>
               <a:rPr sz="2600" b="1">
                 <a:solidFill>
-                  <a:srgbClr val="20190F"/>
-                </a:solidFill>
-                <a:latin typeface="Arial"/>
+                  <a:srgbClr val="111111"/>
+                </a:solidFill>
+                <a:latin typeface="Verdana"/>
               </a:rPr>
               <a:t>•  Write the five fingers, then ask</a:t>
             </a:r>
@@ -7269,9 +7269,9 @@
             <a:r>
               <a:rPr sz="2600" b="1">
                 <a:solidFill>
-                  <a:srgbClr val="20190F"/>
-                </a:solidFill>
-                <a:latin typeface="Arial"/>
+                  <a:srgbClr val="111111"/>
+                </a:solidFill>
+                <a:latin typeface="Verdana"/>
               </a:rPr>
               <a:t>•  Recorder: 3 main points + one "?"</a:t>
             </a:r>
@@ -7293,11 +7293,11 @@
             <a:avLst/>
           </a:prstGeom>
           <a:solidFill>
-            <a:srgbClr val="FBF6EC"/>
+            <a:srgbClr val="FFFFFF"/>
           </a:solidFill>
           <a:ln w="15875">
             <a:solidFill>
-              <a:srgbClr val="E2D8C4"/>
+              <a:srgbClr val="D6336C"/>
             </a:solidFill>
           </a:ln>
           <a:effectLst/>
@@ -7354,9 +7354,9 @@
             <a:r>
               <a:rPr sz="1200" b="1">
                 <a:solidFill>
-                  <a:srgbClr val="C07A1E"/>
-                </a:solidFill>
-                <a:latin typeface="Arial"/>
+                  <a:srgbClr val="1FA3C8"/>
+                </a:solidFill>
+                <a:latin typeface="Verdana"/>
               </a:rPr>
               <a:t>IMAGE · A-IMG-05 · coming</a:t>
             </a:r>
@@ -7393,9 +7393,9 @@
             <a:r>
               <a:rPr sz="1800" b="1">
                 <a:solidFill>
-                  <a:srgbClr val="1F4D2B"/>
-                </a:solidFill>
-                <a:latin typeface="Georgia"/>
+                  <a:srgbClr val="111111"/>
+                </a:solidFill>
+                <a:latin typeface="Impact"/>
               </a:rPr>
               <a:t>The AI desk (facilitator plays the machine)</a:t>
             </a:r>
@@ -7432,9 +7432,9 @@
             <a:r>
               <a:rPr sz="1100" b="0">
                 <a:solidFill>
-                  <a:srgbClr val="20190F"/>
-                </a:solidFill>
-                <a:latin typeface="Arial"/>
+                  <a:srgbClr val="111111"/>
+                </a:solidFill>
+                <a:latin typeface="Verdana"/>
               </a:rPr>
               <a:t>Landscape 16:9. A facilitator (woman, 30s) sits on a chair at the side of a hall wearing a large card on a string round her neck — the card shows a simple drawn phone with a question mark (a drawing, not words). She holds a small stack of cards and reads one in a deadpan, confident way. A group Reporter (young man) stands in front of her with a notebook;…</a:t>
             </a:r>
@@ -7455,7 +7455,7 @@
     <p:bg>
       <p:bgPr>
         <a:solidFill>
-          <a:srgbClr val="F7F2E9"/>
+          <a:srgbClr val="FFFFFF"/>
         </a:solidFill>
         <a:effectLst/>
       </p:bgPr>
@@ -7497,9 +7497,9 @@
             <a:r>
               <a:rPr sz="1000" b="0">
                 <a:solidFill>
-                  <a:srgbClr val="6B6255"/>
-                </a:solidFill>
-                <a:latin typeface="Arial"/>
+                  <a:srgbClr val="111111"/>
+                </a:solidFill>
+                <a:latin typeface="Verdana"/>
               </a:rPr>
               <a:t>A-D1-14   ·   Poster A-P05</a:t>
             </a:r>
@@ -7536,9 +7536,9 @@
             <a:r>
               <a:rPr sz="1000" b="0">
                 <a:solidFill>
-                  <a:srgbClr val="6B6255"/>
-                </a:solidFill>
-                <a:latin typeface="Arial"/>
+                  <a:srgbClr val="111111"/>
+                </a:solidFill>
+                <a:latin typeface="Verdana"/>
               </a:rPr>
               <a:t>AI Literacy</a:t>
             </a:r>
@@ -7560,7 +7560,7 @@
             <a:avLst/>
           </a:prstGeom>
           <a:solidFill>
-            <a:srgbClr val="235E86"/>
+            <a:srgbClr val="D6336C"/>
           </a:solidFill>
           <a:ln>
             <a:noFill/>
@@ -7619,9 +7619,9 @@
             <a:r>
               <a:rPr sz="1200" b="1">
                 <a:solidFill>
-                  <a:srgbClr val="F7F2E9"/>
-                </a:solidFill>
-                <a:latin typeface="Arial"/>
+                  <a:srgbClr val="FFFFFF"/>
+                </a:solidFill>
+                <a:latin typeface="Verdana"/>
               </a:rPr>
               <a:t>APP</a:t>
             </a:r>
@@ -7643,7 +7643,7 @@
             <a:avLst/>
           </a:prstGeom>
           <a:solidFill>
-            <a:srgbClr val="C07A1E"/>
+            <a:srgbClr val="1FA3C8"/>
           </a:solidFill>
           <a:ln>
             <a:noFill/>
@@ -7702,9 +7702,9 @@
             <a:r>
               <a:rPr sz="1400" b="1">
                 <a:solidFill>
-                  <a:srgbClr val="F7F2E9"/>
-                </a:solidFill>
-                <a:latin typeface="Arial"/>
+                  <a:srgbClr val="FFFFFF"/>
+                </a:solidFill>
+                <a:latin typeface="Verdana"/>
               </a:rPr>
               <a:t>YOUR TURN</a:t>
             </a:r>
@@ -7741,9 +7741,9 @@
             <a:r>
               <a:rPr sz="3800" b="1">
                 <a:solidFill>
-                  <a:srgbClr val="1F4D2B"/>
-                </a:solidFill>
-                <a:latin typeface="Georgia"/>
+                  <a:srgbClr val="111111"/>
+                </a:solidFill>
+                <a:latin typeface="Impact"/>
               </a:rPr>
               <a:t>Ask Lima in the app</a:t>
             </a:r>
@@ -7765,7 +7765,7 @@
             <a:avLst/>
           </a:prstGeom>
           <a:solidFill>
-            <a:srgbClr val="E2D8C4"/>
+            <a:srgbClr val="D6336C"/>
           </a:solidFill>
           <a:ln>
             <a:noFill/>
@@ -7824,9 +7824,9 @@
             <a:r>
               <a:rPr sz="2600" b="1">
                 <a:solidFill>
-                  <a:srgbClr val="20190F"/>
-                </a:solidFill>
-                <a:latin typeface="Arial"/>
+                  <a:srgbClr val="111111"/>
+                </a:solidFill>
+                <a:latin typeface="Verdana"/>
               </a:rPr>
               <a:t>•  Open ImbewuField · tap the help strip</a:t>
             </a:r>
@@ -7840,9 +7840,9 @@
             <a:r>
               <a:rPr sz="2600" b="1">
                 <a:solidFill>
-                  <a:srgbClr val="20190F"/>
-                </a:solidFill>
-                <a:latin typeface="Arial"/>
+                  <a:srgbClr val="111111"/>
+                </a:solidFill>
+                <a:latin typeface="Verdana"/>
               </a:rPr>
               <a:t>•  Ask with the whole hand</a:t>
             </a:r>
@@ -7856,9 +7856,9 @@
             <a:r>
               <a:rPr sz="2600" b="1">
                 <a:solidFill>
-                  <a:srgbClr val="20190F"/>
-                </a:solidFill>
-                <a:latin typeface="Arial"/>
+                  <a:srgbClr val="111111"/>
+                </a:solidFill>
+                <a:latin typeface="Verdana"/>
               </a:rPr>
               <a:t>•  Read it aloud in our language</a:t>
             </a:r>
@@ -7880,11 +7880,11 @@
             <a:avLst/>
           </a:prstGeom>
           <a:solidFill>
-            <a:srgbClr val="FBF6EC"/>
+            <a:srgbClr val="FFFFFF"/>
           </a:solidFill>
           <a:ln w="15875">
             <a:solidFill>
-              <a:srgbClr val="E2D8C4"/>
+              <a:srgbClr val="D6336C"/>
             </a:solidFill>
           </a:ln>
           <a:effectLst/>
@@ -7941,9 +7941,9 @@
             <a:r>
               <a:rPr sz="1200" b="1">
                 <a:solidFill>
-                  <a:srgbClr val="C07A1E"/>
-                </a:solidFill>
-                <a:latin typeface="Arial"/>
+                  <a:srgbClr val="1FA3C8"/>
+                </a:solidFill>
+                <a:latin typeface="Verdana"/>
               </a:rPr>
               <a:t>PHOTO · A-PHO-01 · coming</a:t>
             </a:r>
@@ -7980,9 +7980,9 @@
             <a:r>
               <a:rPr sz="1800" b="1">
                 <a:solidFill>
-                  <a:srgbClr val="1F4D2B"/>
-                </a:solidFill>
-                <a:latin typeface="Georgia"/>
+                  <a:srgbClr val="111111"/>
+                </a:solidFill>
+                <a:latin typeface="Impact"/>
               </a:rPr>
               <a:t>Screen: the Lima help strip</a:t>
             </a:r>
@@ -8019,9 +8019,9 @@
             <a:r>
               <a:rPr sz="1100" b="0">
                 <a:solidFill>
-                  <a:srgbClr val="20190F"/>
-                </a:solidFill>
-                <a:latin typeface="Arial"/>
+                  <a:srgbClr val="111111"/>
+                </a:solidFill>
+                <a:latin typeface="Verdana"/>
               </a:rPr>
               <a:t>Screenshot captured on Day 0 from a **sample/demo account** (no real farmer data): ImbewuField Home with the Lima help strip at the bottom, then Lima answering a Question-Hand question about spinach holes. Crop to the phone frame. Recapture before each course if the screen has changed. Blur anything personal.</a:t>
             </a:r>
@@ -8042,7 +8042,7 @@
     <p:bg>
       <p:bgPr>
         <a:solidFill>
-          <a:srgbClr val="1F4D2B"/>
+          <a:srgbClr val="1B1F3B"/>
         </a:solidFill>
         <a:effectLst/>
       </p:bgPr>
@@ -8084,9 +8084,9 @@
             <a:r>
               <a:rPr sz="1000" b="0">
                 <a:solidFill>
-                  <a:srgbClr val="A8D88A"/>
-                </a:solidFill>
-                <a:latin typeface="Arial"/>
+                  <a:srgbClr val="F7C948"/>
+                </a:solidFill>
+                <a:latin typeface="Verdana"/>
               </a:rPr>
               <a:t>A-D1-15   ·   Poster A-P06</a:t>
             </a:r>
@@ -8123,9 +8123,9 @@
             <a:r>
               <a:rPr sz="1000" b="0">
                 <a:solidFill>
-                  <a:srgbClr val="A8D88A"/>
-                </a:solidFill>
-                <a:latin typeface="Arial"/>
+                  <a:srgbClr val="F7C948"/>
+                </a:solidFill>
+                <a:latin typeface="Verdana"/>
               </a:rPr>
               <a:t>AI Literacy</a:t>
             </a:r>
@@ -8162,9 +8162,9 @@
             <a:r>
               <a:rPr sz="4800" b="1">
                 <a:solidFill>
-                  <a:srgbClr val="F7F2E9"/>
-                </a:solidFill>
-                <a:latin typeface="Georgia"/>
+                  <a:srgbClr val="F7C948"/>
+                </a:solidFill>
+                <a:latin typeface="Impact"/>
               </a:rPr>
               <a:t>Say it. Show it.</a:t>
             </a:r>
@@ -8186,7 +8186,7 @@
             <a:avLst/>
           </a:prstGeom>
           <a:solidFill>
-            <a:srgbClr val="C07A1E"/>
+            <a:srgbClr val="1FA3C8"/>
           </a:solidFill>
           <a:ln>
             <a:noFill/>
@@ -8245,9 +8245,9 @@
             <a:r>
               <a:rPr sz="2400" b="0">
                 <a:solidFill>
-                  <a:srgbClr val="A8D88A"/>
-                </a:solidFill>
-                <a:latin typeface="Arial"/>
+                  <a:srgbClr val="F7C948"/>
+                </a:solidFill>
+                <a:latin typeface="Verdana"/>
               </a:rPr>
               <a:t>Your voice and a photo</a:t>
             </a:r>
@@ -8269,11 +8269,11 @@
             <a:avLst/>
           </a:prstGeom>
           <a:solidFill>
-            <a:srgbClr val="FBF6EC"/>
+            <a:srgbClr val="FFFFFF"/>
           </a:solidFill>
           <a:ln w="15875">
             <a:solidFill>
-              <a:srgbClr val="E2D8C4"/>
+              <a:srgbClr val="D6336C"/>
             </a:solidFill>
           </a:ln>
           <a:effectLst/>
@@ -8330,9 +8330,9 @@
             <a:r>
               <a:rPr sz="1200" b="1">
                 <a:solidFill>
-                  <a:srgbClr val="C07A1E"/>
-                </a:solidFill>
-                <a:latin typeface="Arial"/>
+                  <a:srgbClr val="1FA3C8"/>
+                </a:solidFill>
+                <a:latin typeface="Verdana"/>
               </a:rPr>
               <a:t>POSTER ART · A-P06-ART · coming</a:t>
             </a:r>
@@ -8369,9 +8369,9 @@
             <a:r>
               <a:rPr sz="1800" b="1">
                 <a:solidFill>
-                  <a:srgbClr val="1F4D2B"/>
-                </a:solidFill>
-                <a:latin typeface="Georgia"/>
+                  <a:srgbClr val="111111"/>
+                </a:solidFill>
+                <a:latin typeface="Impact"/>
               </a:rPr>
               <a:t>Artwork for A-P06 · Ask with your voice and a photo</a:t>
             </a:r>
@@ -8408,9 +8408,9 @@
             <a:r>
               <a:rPr sz="1100" b="0">
                 <a:solidFill>
-                  <a:srgbClr val="20190F"/>
-                </a:solidFill>
-                <a:latin typeface="Arial"/>
+                  <a:srgbClr val="111111"/>
+                </a:solidFill>
+                <a:latin typeface="Verdana"/>
               </a:rPr>
               <a:t>Top half: an older man speaking into a phone held near his mouth, a sound-wave shape flowing into the phone; a small keyboard with a microphone key glows. Bottom half: a young woman crouched by a bed, photographing a single leaf with holes. Sun behind her in the **north** (upper part of the sky, compass rose in the corner showing N up), her shadow…</a:t>
             </a:r>
@@ -8431,7 +8431,7 @@
     <p:bg>
       <p:bgPr>
         <a:solidFill>
-          <a:srgbClr val="F7F2E9"/>
+          <a:srgbClr val="FFFFFF"/>
         </a:solidFill>
         <a:effectLst/>
       </p:bgPr>
@@ -8473,9 +8473,9 @@
             <a:r>
               <a:rPr sz="1000" b="0">
                 <a:solidFill>
-                  <a:srgbClr val="6B6255"/>
-                </a:solidFill>
-                <a:latin typeface="Arial"/>
+                  <a:srgbClr val="111111"/>
+                </a:solidFill>
+                <a:latin typeface="Verdana"/>
               </a:rPr>
               <a:t>A-D1-16   ·   Poster A-P06</a:t>
             </a:r>
@@ -8512,9 +8512,9 @@
             <a:r>
               <a:rPr sz="1000" b="0">
                 <a:solidFill>
-                  <a:srgbClr val="6B6255"/>
-                </a:solidFill>
-                <a:latin typeface="Arial"/>
+                  <a:srgbClr val="111111"/>
+                </a:solidFill>
+                <a:latin typeface="Verdana"/>
               </a:rPr>
               <a:t>AI Literacy</a:t>
             </a:r>
@@ -8551,9 +8551,9 @@
             <a:r>
               <a:rPr sz="3800" b="1">
                 <a:solidFill>
-                  <a:srgbClr val="1F4D2B"/>
-                </a:solidFill>
-                <a:latin typeface="Georgia"/>
+                  <a:srgbClr val="111111"/>
+                </a:solidFill>
+                <a:latin typeface="Impact"/>
               </a:rPr>
               <a:t>A clear photo</a:t>
             </a:r>
@@ -8575,7 +8575,7 @@
             <a:avLst/>
           </a:prstGeom>
           <a:solidFill>
-            <a:srgbClr val="E2D8C4"/>
+            <a:srgbClr val="D6336C"/>
           </a:solidFill>
           <a:ln>
             <a:noFill/>
@@ -8634,9 +8634,9 @@
             <a:r>
               <a:rPr sz="2400" b="0">
                 <a:solidFill>
-                  <a:srgbClr val="20190F"/>
-                </a:solidFill>
-                <a:latin typeface="Arial"/>
+                  <a:srgbClr val="111111"/>
+                </a:solidFill>
+                <a:latin typeface="Verdana"/>
               </a:rPr>
               <a:t>•  Light behind you · close · still</a:t>
             </a:r>
@@ -8650,9 +8650,9 @@
             <a:r>
               <a:rPr sz="2400" b="0">
                 <a:solidFill>
-                  <a:srgbClr val="20190F"/>
-                </a:solidFill>
-                <a:latin typeface="Arial"/>
+                  <a:srgbClr val="111111"/>
+                </a:solidFill>
+                <a:latin typeface="Verdana"/>
               </a:rPr>
               <a:t>•  One thing · show the size</a:t>
             </a:r>
@@ -8666,9 +8666,9 @@
             <a:r>
               <a:rPr sz="2400" b="0">
                 <a:solidFill>
-                  <a:srgbClr val="20190F"/>
-                </a:solidFill>
-                <a:latin typeface="Arial"/>
+                  <a:srgbClr val="111111"/>
+                </a:solidFill>
+                <a:latin typeface="Verdana"/>
               </a:rPr>
               <a:t>•  Ask before a person is in it</a:t>
             </a:r>
@@ -8690,11 +8690,11 @@
             <a:avLst/>
           </a:prstGeom>
           <a:solidFill>
-            <a:srgbClr val="FBF6EC"/>
+            <a:srgbClr val="FFFFFF"/>
           </a:solidFill>
           <a:ln w="15875">
             <a:solidFill>
-              <a:srgbClr val="E2D8C4"/>
+              <a:srgbClr val="D6336C"/>
             </a:solidFill>
           </a:ln>
           <a:effectLst/>
@@ -8751,9 +8751,9 @@
             <a:r>
               <a:rPr sz="1200" b="1">
                 <a:solidFill>
-                  <a:srgbClr val="C07A1E"/>
-                </a:solidFill>
-                <a:latin typeface="Arial"/>
+                  <a:srgbClr val="1FA3C8"/>
+                </a:solidFill>
+                <a:latin typeface="Verdana"/>
               </a:rPr>
               <a:t>ANIMATION · A-ANI-02 · coming</a:t>
             </a:r>
@@ -8790,9 +8790,9 @@
             <a:r>
               <a:rPr sz="1800" b="1">
                 <a:solidFill>
-                  <a:srgbClr val="1F4D2B"/>
-                </a:solidFill>
-                <a:latin typeface="Georgia"/>
+                  <a:srgbClr val="111111"/>
+                </a:solidFill>
+                <a:latin typeface="Impact"/>
               </a:rPr>
               <a:t>Good photo, bad photo</a:t>
             </a:r>
@@ -8829,9 +8829,9 @@
             <a:r>
               <a:rPr sz="1100" b="0">
                 <a:solidFill>
-                  <a:srgbClr val="20190F"/>
-                </a:solidFill>
-                <a:latin typeface="Arial"/>
+                  <a:srgbClr val="111111"/>
+                </a:solidFill>
+                <a:latin typeface="Verdana"/>
               </a:rPr>
               <a:t>Phone camera view of a leaf with holes. 0–3 s: dark, blurry, far away, sun flaring in the lens. 3–6 s: the photographer turns so the sun (north, top of sky) is behind her — flare gone. 6–9 s: phone moves close; leaf fills the frame. 9–11 s: a finger taps the leaf — it snaps sharp. 11–13 s: a flat hand slides in beside the leaf for size; a tick appears.…</a:t>
             </a:r>
@@ -8852,7 +8852,7 @@
     <p:bg>
       <p:bgPr>
         <a:solidFill>
-          <a:srgbClr val="F7F2E9"/>
+          <a:srgbClr val="FFFFFF"/>
         </a:solidFill>
         <a:effectLst/>
       </p:bgPr>
@@ -8894,9 +8894,9 @@
             <a:r>
               <a:rPr sz="1000" b="0">
                 <a:solidFill>
-                  <a:srgbClr val="6B6255"/>
-                </a:solidFill>
-                <a:latin typeface="Arial"/>
+                  <a:srgbClr val="111111"/>
+                </a:solidFill>
+                <a:latin typeface="Verdana"/>
               </a:rPr>
               <a:t>A-D1-17   ·   Poster A-P06</a:t>
             </a:r>
@@ -8933,9 +8933,9 @@
             <a:r>
               <a:rPr sz="1000" b="0">
                 <a:solidFill>
-                  <a:srgbClr val="6B6255"/>
-                </a:solidFill>
-                <a:latin typeface="Arial"/>
+                  <a:srgbClr val="111111"/>
+                </a:solidFill>
+                <a:latin typeface="Verdana"/>
               </a:rPr>
               <a:t>AI Literacy</a:t>
             </a:r>
@@ -8957,7 +8957,7 @@
             <a:avLst/>
           </a:prstGeom>
           <a:solidFill>
-            <a:srgbClr val="C07A1E"/>
+            <a:srgbClr val="1FA3C8"/>
           </a:solidFill>
           <a:ln>
             <a:noFill/>
@@ -9016,9 +9016,9 @@
             <a:r>
               <a:rPr sz="1400" b="1">
                 <a:solidFill>
-                  <a:srgbClr val="F7F2E9"/>
-                </a:solidFill>
-                <a:latin typeface="Arial"/>
+                  <a:srgbClr val="FFFFFF"/>
+                </a:solidFill>
+                <a:latin typeface="Verdana"/>
               </a:rPr>
               <a:t>YOUR TURN</a:t>
             </a:r>
@@ -9055,9 +9055,9 @@
             <a:r>
               <a:rPr sz="3800" b="1">
                 <a:solidFill>
-                  <a:srgbClr val="1F4D2B"/>
-                </a:solidFill>
-                <a:latin typeface="Georgia"/>
+                  <a:srgbClr val="111111"/>
+                </a:solidFill>
+                <a:latin typeface="Impact"/>
               </a:rPr>
               <a:t>Photo stations</a:t>
             </a:r>
@@ -9079,7 +9079,7 @@
             <a:avLst/>
           </a:prstGeom>
           <a:solidFill>
-            <a:srgbClr val="E2D8C4"/>
+            <a:srgbClr val="D6336C"/>
           </a:solidFill>
           <a:ln>
             <a:noFill/>
@@ -9138,9 +9138,9 @@
             <a:r>
               <a:rPr sz="2600" b="1">
                 <a:solidFill>
-                  <a:srgbClr val="20190F"/>
-                </a:solidFill>
-                <a:latin typeface="Arial"/>
+                  <a:srgbClr val="111111"/>
+                </a:solidFill>
+                <a:latin typeface="Verdana"/>
               </a:rPr>
               <a:t>•  Plant · Weigh · Tree — 12 min each</a:t>
             </a:r>
@@ -9154,9 +9154,9 @@
             <a:r>
               <a:rPr sz="2600" b="1">
                 <a:solidFill>
-                  <a:srgbClr val="20190F"/>
-                </a:solidFill>
-                <a:latin typeface="Arial"/>
+                  <a:srgbClr val="111111"/>
+                </a:solidFill>
+                <a:latin typeface="Verdana"/>
               </a:rPr>
               <a:t>•  What did AI say? How sure?</a:t>
             </a:r>
@@ -9170,9 +9170,9 @@
             <a:r>
               <a:rPr sz="2600" b="1">
                 <a:solidFill>
-                  <a:srgbClr val="20190F"/>
-                </a:solidFill>
-                <a:latin typeface="Arial"/>
+                  <a:srgbClr val="111111"/>
+                </a:solidFill>
+                <a:latin typeface="Verdana"/>
               </a:rPr>
               <a:t>•  How did we check? Right?</a:t>
             </a:r>
@@ -9194,11 +9194,11 @@
             <a:avLst/>
           </a:prstGeom>
           <a:solidFill>
-            <a:srgbClr val="FBF6EC"/>
+            <a:srgbClr val="FFFFFF"/>
           </a:solidFill>
           <a:ln w="15875">
             <a:solidFill>
-              <a:srgbClr val="E2D8C4"/>
+              <a:srgbClr val="D6336C"/>
             </a:solidFill>
           </a:ln>
           <a:effectLst/>
@@ -9255,9 +9255,9 @@
             <a:r>
               <a:rPr sz="1200" b="1">
                 <a:solidFill>
-                  <a:srgbClr val="C07A1E"/>
-                </a:solidFill>
-                <a:latin typeface="Arial"/>
+                  <a:srgbClr val="1FA3C8"/>
+                </a:solidFill>
+                <a:latin typeface="Verdana"/>
               </a:rPr>
               <a:t>IMAGE · A-IMG-03 · coming</a:t>
             </a:r>
@@ -9294,9 +9294,9 @@
             <a:r>
               <a:rPr sz="1800" b="1">
                 <a:solidFill>
-                  <a:srgbClr val="1F4D2B"/>
-                </a:solidFill>
-                <a:latin typeface="Georgia"/>
+                  <a:srgbClr val="111111"/>
+                </a:solidFill>
+                <a:latin typeface="Impact"/>
               </a:rPr>
               <a:t>Weigh it to check it</a:t>
             </a:r>
@@ -9333,9 +9333,9 @@
             <a:r>
               <a:rPr sz="1100" b="0">
                 <a:solidFill>
-                  <a:srgbClr val="20190F"/>
-                </a:solidFill>
-                <a:latin typeface="Arial"/>
+                  <a:srgbClr val="111111"/>
+                </a:solidFill>
+                <a:latin typeface="Verdana"/>
               </a:rPr>
               <a:t>Landscape 16:9. At a table outside, a young man photographs a bag of carrots and potatoes with a 2 ℓ plastic water bottle beside it for size. Next to him, an older woman places the same bag on a simple kitchen scale; the dial pointer is visible (no numbers readable). The two look at each other, comparing. Station feel: other groups in the background at a…</a:t>
             </a:r>
@@ -9356,7 +9356,7 @@
     <p:bg>
       <p:bgPr>
         <a:solidFill>
-          <a:srgbClr val="F7F2E9"/>
+          <a:srgbClr val="FFFFFF"/>
         </a:solidFill>
         <a:effectLst/>
       </p:bgPr>
@@ -9398,9 +9398,9 @@
             <a:r>
               <a:rPr sz="1000" b="0">
                 <a:solidFill>
-                  <a:srgbClr val="6B6255"/>
-                </a:solidFill>
-                <a:latin typeface="Arial"/>
+                  <a:srgbClr val="111111"/>
+                </a:solidFill>
+                <a:latin typeface="Verdana"/>
               </a:rPr>
               <a:t>A-D1-18   ·   Poster A-P06</a:t>
             </a:r>
@@ -9437,9 +9437,9 @@
             <a:r>
               <a:rPr sz="1000" b="0">
                 <a:solidFill>
-                  <a:srgbClr val="6B6255"/>
-                </a:solidFill>
-                <a:latin typeface="Arial"/>
+                  <a:srgbClr val="111111"/>
+                </a:solidFill>
+                <a:latin typeface="Verdana"/>
               </a:rPr>
               <a:t>AI Literacy</a:t>
             </a:r>
@@ -9461,7 +9461,7 @@
             <a:avLst/>
           </a:prstGeom>
           <a:solidFill>
-            <a:srgbClr val="235E86"/>
+            <a:srgbClr val="D6336C"/>
           </a:solidFill>
           <a:ln>
             <a:noFill/>
@@ -9520,9 +9520,9 @@
             <a:r>
               <a:rPr sz="1200" b="1">
                 <a:solidFill>
-                  <a:srgbClr val="F7F2E9"/>
-                </a:solidFill>
-                <a:latin typeface="Arial"/>
+                  <a:srgbClr val="FFFFFF"/>
+                </a:solidFill>
+                <a:latin typeface="Verdana"/>
               </a:rPr>
               <a:t>APP</a:t>
             </a:r>
@@ -9544,7 +9544,7 @@
             <a:avLst/>
           </a:prstGeom>
           <a:solidFill>
-            <a:srgbClr val="C07A1E"/>
+            <a:srgbClr val="1FA3C8"/>
           </a:solidFill>
           <a:ln>
             <a:noFill/>
@@ -9603,9 +9603,9 @@
             <a:r>
               <a:rPr sz="1400" b="1">
                 <a:solidFill>
-                  <a:srgbClr val="F7F2E9"/>
-                </a:solidFill>
-                <a:latin typeface="Arial"/>
+                  <a:srgbClr val="FFFFFF"/>
+                </a:solidFill>
+                <a:latin typeface="Verdana"/>
               </a:rPr>
               <a:t>YOUR TURN</a:t>
             </a:r>
@@ -9642,9 +9642,9 @@
             <a:r>
               <a:rPr sz="3800" b="1">
                 <a:solidFill>
-                  <a:srgbClr val="1F4D2B"/>
-                </a:solidFill>
-                <a:latin typeface="Georgia"/>
+                  <a:srgbClr val="111111"/>
+                </a:solidFill>
+                <a:latin typeface="Impact"/>
               </a:rPr>
               <a:t>Lima Vision and Tree ID</a:t>
             </a:r>
@@ -9666,7 +9666,7 @@
             <a:avLst/>
           </a:prstGeom>
           <a:solidFill>
-            <a:srgbClr val="E2D8C4"/>
+            <a:srgbClr val="D6336C"/>
           </a:solidFill>
           <a:ln>
             <a:noFill/>
@@ -9725,9 +9725,9 @@
             <a:r>
               <a:rPr sz="2600" b="1">
                 <a:solidFill>
-                  <a:srgbClr val="20190F"/>
-                </a:solidFill>
-                <a:latin typeface="Arial"/>
+                  <a:srgbClr val="111111"/>
+                </a:solidFill>
+                <a:latin typeface="Verdana"/>
               </a:rPr>
               <a:t>•  What's growing? · Weigh my harvest</a:t>
             </a:r>
@@ -9741,9 +9741,9 @@
             <a:r>
               <a:rPr sz="2600" b="1">
                 <a:solidFill>
-                  <a:srgbClr val="20190F"/>
-                </a:solidFill>
-                <a:latin typeface="Arial"/>
+                  <a:srgbClr val="111111"/>
+                </a:solidFill>
+                <a:latin typeface="Verdana"/>
               </a:rPr>
               <a:t>•  Tree ID on the venue tree</a:t>
             </a:r>
@@ -9757,9 +9757,9 @@
             <a:r>
               <a:rPr sz="2600" b="1">
                 <a:solidFill>
-                  <a:srgbClr val="20190F"/>
-                </a:solidFill>
-                <a:latin typeface="Arial"/>
+                  <a:srgbClr val="111111"/>
+                </a:solidFill>
+                <a:latin typeface="Verdana"/>
               </a:rPr>
               <a:t>•  Low confidence = a guess</a:t>
             </a:r>
@@ -9781,11 +9781,11 @@
             <a:avLst/>
           </a:prstGeom>
           <a:solidFill>
-            <a:srgbClr val="FBF6EC"/>
+            <a:srgbClr val="FFFFFF"/>
           </a:solidFill>
           <a:ln w="15875">
             <a:solidFill>
-              <a:srgbClr val="E2D8C4"/>
+              <a:srgbClr val="D6336C"/>
             </a:solidFill>
           </a:ln>
           <a:effectLst/>
@@ -9842,9 +9842,9 @@
             <a:r>
               <a:rPr sz="1200" b="1">
                 <a:solidFill>
-                  <a:srgbClr val="C07A1E"/>
-                </a:solidFill>
-                <a:latin typeface="Arial"/>
+                  <a:srgbClr val="1FA3C8"/>
+                </a:solidFill>
+                <a:latin typeface="Verdana"/>
               </a:rPr>
               <a:t>PHOTO · A-PHO-03 · coming</a:t>
             </a:r>
@@ -9881,9 +9881,9 @@
             <a:r>
               <a:rPr sz="1800" b="1">
                 <a:solidFill>
-                  <a:srgbClr val="1F4D2B"/>
-                </a:solidFill>
-                <a:latin typeface="Georgia"/>
+                  <a:srgbClr val="111111"/>
+                </a:solidFill>
+                <a:latin typeface="Impact"/>
               </a:rPr>
               <a:t>Screen: Lima Vision result</a:t>
             </a:r>
@@ -9920,9 +9920,9 @@
             <a:r>
               <a:rPr sz="1100" b="0">
                 <a:solidFill>
-                  <a:srgbClr val="20190F"/>
-                </a:solidFill>
-                <a:latin typeface="Arial"/>
+                  <a:srgbClr val="111111"/>
+                </a:solidFill>
+                <a:latin typeface="Verdana"/>
               </a:rPr>
               <a:t>Two screenshots from a demo account: "What's growing" result (crop, rough kg, weeks to harvest, confidence pill) and "Weigh my harvest" result (estimated kg, confidence pill). Use a real test photo of a bed and of produce beside a 2 ℓ bottle.</a:t>
             </a:r>
@@ -9943,7 +9943,7 @@
     <p:bg>
       <p:bgPr>
         <a:solidFill>
-          <a:srgbClr val="F7F2E9"/>
+          <a:srgbClr val="FFFFFF"/>
         </a:solidFill>
         <a:effectLst/>
       </p:bgPr>
@@ -9985,9 +9985,9 @@
             <a:r>
               <a:rPr sz="1000" b="0">
                 <a:solidFill>
-                  <a:srgbClr val="6B6255"/>
-                </a:solidFill>
-                <a:latin typeface="Arial"/>
+                  <a:srgbClr val="111111"/>
+                </a:solidFill>
+                <a:latin typeface="Verdana"/>
               </a:rPr>
               <a:t>A-D1-19   ·   Poster A-P06</a:t>
             </a:r>
@@ -10024,9 +10024,9 @@
             <a:r>
               <a:rPr sz="1000" b="0">
                 <a:solidFill>
-                  <a:srgbClr val="6B6255"/>
-                </a:solidFill>
-                <a:latin typeface="Arial"/>
+                  <a:srgbClr val="111111"/>
+                </a:solidFill>
+                <a:latin typeface="Verdana"/>
               </a:rPr>
               <a:t>AI Literacy</a:t>
             </a:r>
@@ -10063,9 +10063,9 @@
             <a:r>
               <a:rPr sz="3800" b="1">
                 <a:solidFill>
-                  <a:srgbClr val="1F4D2B"/>
-                </a:solidFill>
-                <a:latin typeface="Georgia"/>
+                  <a:srgbClr val="111111"/>
+                </a:solidFill>
+                <a:latin typeface="Impact"/>
               </a:rPr>
               <a:t>What did we learn from photos?</a:t>
             </a:r>
@@ -10087,7 +10087,7 @@
             <a:avLst/>
           </a:prstGeom>
           <a:solidFill>
-            <a:srgbClr val="E2D8C4"/>
+            <a:srgbClr val="D6336C"/>
           </a:solidFill>
           <a:ln>
             <a:noFill/>
@@ -10146,9 +10146,9 @@
             <a:r>
               <a:rPr sz="2800" b="0">
                 <a:solidFill>
-                  <a:srgbClr val="20190F"/>
-                </a:solidFill>
-                <a:latin typeface="Arial"/>
+                  <a:srgbClr val="111111"/>
+                </a:solidFill>
+                <a:latin typeface="Verdana"/>
               </a:rPr>
               <a:t>•  What did AI get right? Wrong?</a:t>
             </a:r>
@@ -10162,9 +10162,9 @@
             <a:r>
               <a:rPr sz="2800" b="0">
                 <a:solidFill>
-                  <a:srgbClr val="20190F"/>
-                </a:solidFill>
-                <a:latin typeface="Arial"/>
+                  <a:srgbClr val="111111"/>
+                </a:solidFill>
+                <a:latin typeface="Verdana"/>
               </a:rPr>
               <a:t>•  How did we check?</a:t>
             </a:r>
@@ -10178,9 +10178,9 @@
             <a:r>
               <a:rPr sz="2800" b="0">
                 <a:solidFill>
-                  <a:srgbClr val="20190F"/>
-                </a:solidFill>
-                <a:latin typeface="Arial"/>
+                  <a:srgbClr val="111111"/>
+                </a:solidFill>
+                <a:latin typeface="Verdana"/>
               </a:rPr>
               <a:t>•  The scale wins</a:t>
             </a:r>
@@ -10202,11 +10202,11 @@
             <a:avLst/>
           </a:prstGeom>
           <a:solidFill>
-            <a:srgbClr val="FBF6EC"/>
+            <a:srgbClr val="FFFFFF"/>
           </a:solidFill>
           <a:ln w="15875">
             <a:solidFill>
-              <a:srgbClr val="E2D8C4"/>
+              <a:srgbClr val="D6336C"/>
             </a:solidFill>
           </a:ln>
           <a:effectLst/>
@@ -10263,9 +10263,9 @@
             <a:r>
               <a:rPr sz="1200" b="1">
                 <a:solidFill>
-                  <a:srgbClr val="C07A1E"/>
-                </a:solidFill>
-                <a:latin typeface="Arial"/>
+                  <a:srgbClr val="1FA3C8"/>
+                </a:solidFill>
+                <a:latin typeface="Verdana"/>
               </a:rPr>
               <a:t>IMAGE · A-IMG-03 · coming</a:t>
             </a:r>
@@ -10302,9 +10302,9 @@
             <a:r>
               <a:rPr sz="1800" b="1">
                 <a:solidFill>
-                  <a:srgbClr val="1F4D2B"/>
-                </a:solidFill>
-                <a:latin typeface="Georgia"/>
+                  <a:srgbClr val="111111"/>
+                </a:solidFill>
+                <a:latin typeface="Impact"/>
               </a:rPr>
               <a:t>Weigh it to check it</a:t>
             </a:r>
@@ -10341,9 +10341,9 @@
             <a:r>
               <a:rPr sz="1100" b="0">
                 <a:solidFill>
-                  <a:srgbClr val="20190F"/>
-                </a:solidFill>
-                <a:latin typeface="Arial"/>
+                  <a:srgbClr val="111111"/>
+                </a:solidFill>
+                <a:latin typeface="Verdana"/>
               </a:rPr>
               <a:t>Landscape 16:9. At a table outside, a young man photographs a bag of carrots and potatoes with a 2 ℓ plastic water bottle beside it for size. Next to him, an older woman places the same bag on a simple kitchen scale; the dial pointer is visible (no numbers readable). The two look at each other, comparing. Station feel: other groups in the background at a…</a:t>
             </a:r>
@@ -10364,7 +10364,7 @@
     <p:bg>
       <p:bgPr>
         <a:solidFill>
-          <a:srgbClr val="F7F2E9"/>
+          <a:srgbClr val="FFFFFF"/>
         </a:solidFill>
         <a:effectLst/>
       </p:bgPr>
@@ -10406,9 +10406,9 @@
             <a:r>
               <a:rPr sz="1000" b="0">
                 <a:solidFill>
-                  <a:srgbClr val="6B6255"/>
-                </a:solidFill>
-                <a:latin typeface="Arial"/>
+                  <a:srgbClr val="111111"/>
+                </a:solidFill>
+                <a:latin typeface="Verdana"/>
               </a:rPr>
               <a:t>A-D1-02   ·   Poster A-P01</a:t>
             </a:r>
@@ -10445,9 +10445,9 @@
             <a:r>
               <a:rPr sz="1000" b="0">
                 <a:solidFill>
-                  <a:srgbClr val="6B6255"/>
-                </a:solidFill>
-                <a:latin typeface="Arial"/>
+                  <a:srgbClr val="111111"/>
+                </a:solidFill>
+                <a:latin typeface="Verdana"/>
               </a:rPr>
               <a:t>AI Literacy</a:t>
             </a:r>
@@ -10484,9 +10484,9 @@
             <a:r>
               <a:rPr sz="3800" b="1">
                 <a:solidFill>
-                  <a:srgbClr val="1F4D2B"/>
-                </a:solidFill>
-                <a:latin typeface="Georgia"/>
+                  <a:srgbClr val="111111"/>
+                </a:solidFill>
+                <a:latin typeface="Impact"/>
               </a:rPr>
               <a:t>Learn together, phones too</a:t>
             </a:r>
@@ -10508,7 +10508,7 @@
             <a:avLst/>
           </a:prstGeom>
           <a:solidFill>
-            <a:srgbClr val="E2D8C4"/>
+            <a:srgbClr val="D6336C"/>
           </a:solidFill>
           <a:ln>
             <a:noFill/>
@@ -10567,9 +10567,9 @@
             <a:r>
               <a:rPr sz="2400" b="0">
                 <a:solidFill>
-                  <a:srgbClr val="20190F"/>
-                </a:solidFill>
-                <a:latin typeface="Arial"/>
+                  <a:srgbClr val="111111"/>
+                </a:solidFill>
+                <a:latin typeface="Verdana"/>
               </a:rPr>
               <a:t>•  Phones silent, not away</a:t>
             </a:r>
@@ -10583,9 +10583,9 @@
             <a:r>
               <a:rPr sz="2400" b="0">
                 <a:solidFill>
-                  <a:srgbClr val="20190F"/>
-                </a:solidFill>
-                <a:latin typeface="Arial"/>
+                  <a:srgbClr val="111111"/>
+                </a:solidFill>
+                <a:latin typeface="Verdana"/>
               </a:rPr>
               <a:t>•  Share the turn; ask before photos</a:t>
             </a:r>
@@ -10599,9 +10599,9 @@
             <a:r>
               <a:rPr sz="2400" b="0">
                 <a:solidFill>
-                  <a:srgbClr val="20190F"/>
-                </a:solidFill>
-                <a:latin typeface="Arial"/>
+                  <a:srgbClr val="111111"/>
+                </a:solidFill>
+                <a:latin typeface="Verdana"/>
               </a:rPr>
               <a:t>•  Private stays private</a:t>
             </a:r>
@@ -10623,11 +10623,11 @@
             <a:avLst/>
           </a:prstGeom>
           <a:solidFill>
-            <a:srgbClr val="FBF6EC"/>
+            <a:srgbClr val="FFFFFF"/>
           </a:solidFill>
           <a:ln w="15875">
             <a:solidFill>
-              <a:srgbClr val="E2D8C4"/>
+              <a:srgbClr val="D6336C"/>
             </a:solidFill>
           </a:ln>
           <a:effectLst/>
@@ -10684,9 +10684,9 @@
             <a:r>
               <a:rPr sz="1200" b="1">
                 <a:solidFill>
-                  <a:srgbClr val="C07A1E"/>
-                </a:solidFill>
-                <a:latin typeface="Arial"/>
+                  <a:srgbClr val="1FA3C8"/>
+                </a:solidFill>
+                <a:latin typeface="Verdana"/>
               </a:rPr>
               <a:t>POSTER ART · A-P01-ART · coming</a:t>
             </a:r>
@@ -10723,9 +10723,9 @@
             <a:r>
               <a:rPr sz="1800" b="1">
                 <a:solidFill>
-                  <a:srgbClr val="1F4D2B"/>
-                </a:solidFill>
-                <a:latin typeface="Georgia"/>
+                  <a:srgbClr val="111111"/>
+                </a:solidFill>
+                <a:latin typeface="Impact"/>
               </a:rPr>
               <a:t>Artwork for A-P01 · Our class and phone agreement</a:t>
             </a:r>
@@ -10762,9 +10762,9 @@
             <a:r>
               <a:rPr sz="1100" b="0">
                 <a:solidFill>
-                  <a:srgbClr val="20190F"/>
-                </a:solidFill>
-                <a:latin typeface="Arial"/>
+                  <a:srgbClr val="111111"/>
+                </a:solidFill>
+                <a:latin typeface="Verdana"/>
               </a:rPr>
               <a:t>A circle of eight seated learners of mixed ages and genders under a tree — a gogo with a headscarf, a young man in a cap, a young woman, an older man with a walking stick. Two pairs lean over one shared phone together, smiling. A third phone lies face-down on a knee (silent). One young woman holds up a hand to a person with a phone camera, palm out,…</a:t>
             </a:r>
@@ -10785,7 +10785,7 @@
     <p:bg>
       <p:bgPr>
         <a:solidFill>
-          <a:srgbClr val="F7F2E9"/>
+          <a:srgbClr val="FFFFFF"/>
         </a:solidFill>
         <a:effectLst/>
       </p:bgPr>
@@ -10827,9 +10827,9 @@
             <a:r>
               <a:rPr sz="1000" b="0">
                 <a:solidFill>
-                  <a:srgbClr val="6B6255"/>
-                </a:solidFill>
-                <a:latin typeface="Arial"/>
+                  <a:srgbClr val="111111"/>
+                </a:solidFill>
+                <a:latin typeface="Verdana"/>
               </a:rPr>
               <a:t>A-D1-20   ·   Poster A-P05</a:t>
             </a:r>
@@ -10866,9 +10866,9 @@
             <a:r>
               <a:rPr sz="1000" b="0">
                 <a:solidFill>
-                  <a:srgbClr val="6B6255"/>
-                </a:solidFill>
-                <a:latin typeface="Arial"/>
+                  <a:srgbClr val="111111"/>
+                </a:solidFill>
+                <a:latin typeface="Verdana"/>
               </a:rPr>
               <a:t>AI Literacy</a:t>
             </a:r>
@@ -10890,7 +10890,7 @@
             <a:avLst/>
           </a:prstGeom>
           <a:solidFill>
-            <a:srgbClr val="C07A1E"/>
+            <a:srgbClr val="1FA3C8"/>
           </a:solidFill>
           <a:ln>
             <a:noFill/>
@@ -10949,9 +10949,9 @@
             <a:r>
               <a:rPr sz="1400" b="1">
                 <a:solidFill>
-                  <a:srgbClr val="F7F2E9"/>
-                </a:solidFill>
-                <a:latin typeface="Arial"/>
+                  <a:srgbClr val="FFFFFF"/>
+                </a:solidFill>
+                <a:latin typeface="Verdana"/>
               </a:rPr>
               <a:t>YOUR TURN</a:t>
             </a:r>
@@ -10988,9 +10988,9 @@
             <a:r>
               <a:rPr sz="3800" b="1">
                 <a:solidFill>
-                  <a:srgbClr val="1F4D2B"/>
-                </a:solidFill>
-                <a:latin typeface="Georgia"/>
+                  <a:srgbClr val="111111"/>
+                </a:solidFill>
+                <a:latin typeface="Impact"/>
               </a:rPr>
               <a:t>My real farm question</a:t>
             </a:r>
@@ -11012,7 +11012,7 @@
             <a:avLst/>
           </a:prstGeom>
           <a:solidFill>
-            <a:srgbClr val="E2D8C4"/>
+            <a:srgbClr val="D6336C"/>
           </a:solidFill>
           <a:ln>
             <a:noFill/>
@@ -11071,9 +11071,9 @@
             <a:r>
               <a:rPr sz="3000" b="1">
                 <a:solidFill>
-                  <a:srgbClr val="20190F"/>
-                </a:solidFill>
-                <a:latin typeface="Arial"/>
+                  <a:srgbClr val="111111"/>
+                </a:solidFill>
+                <a:latin typeface="Verdana"/>
               </a:rPr>
               <a:t>•  Build it with five fingers</a:t>
             </a:r>
@@ -11087,9 +11087,9 @@
             <a:r>
               <a:rPr sz="3000" b="1">
                 <a:solidFill>
-                  <a:srgbClr val="20190F"/>
-                </a:solidFill>
-                <a:latin typeface="Arial"/>
+                  <a:srgbClr val="111111"/>
+                </a:solidFill>
+                <a:latin typeface="Verdana"/>
               </a:rPr>
               <a:t>•  Ask it — voice or typing</a:t>
             </a:r>
@@ -11103,9 +11103,9 @@
             <a:r>
               <a:rPr sz="3000" b="1">
                 <a:solidFill>
-                  <a:srgbClr val="20190F"/>
-                </a:solidFill>
-                <a:latin typeface="Arial"/>
+                  <a:srgbClr val="111111"/>
+                </a:solidFill>
+                <a:latin typeface="Verdana"/>
               </a:rPr>
               <a:t>•  How bad if wrong? Colour it</a:t>
             </a:r>
@@ -11127,11 +11127,11 @@
             <a:avLst/>
           </a:prstGeom>
           <a:solidFill>
-            <a:srgbClr val="FBF6EC"/>
+            <a:srgbClr val="FFFFFF"/>
           </a:solidFill>
           <a:ln w="15875">
             <a:solidFill>
-              <a:srgbClr val="E2D8C4"/>
+              <a:srgbClr val="D6336C"/>
             </a:solidFill>
           </a:ln>
           <a:effectLst/>
@@ -11188,9 +11188,9 @@
             <a:r>
               <a:rPr sz="1200" b="1">
                 <a:solidFill>
-                  <a:srgbClr val="C07A1E"/>
-                </a:solidFill>
-                <a:latin typeface="Arial"/>
+                  <a:srgbClr val="1FA3C8"/>
+                </a:solidFill>
+                <a:latin typeface="Verdana"/>
               </a:rPr>
               <a:t>POSTER ART · A-P05-ART · coming</a:t>
             </a:r>
@@ -11227,9 +11227,9 @@
             <a:r>
               <a:rPr sz="1800" b="1">
                 <a:solidFill>
-                  <a:srgbClr val="1F4D2B"/>
-                </a:solidFill>
-                <a:latin typeface="Georgia"/>
+                  <a:srgbClr val="111111"/>
+                </a:solidFill>
+                <a:latin typeface="Impact"/>
               </a:rPr>
               <a:t>Artwork for A-P05 · The Question Hand</a:t>
             </a:r>
@@ -11266,9 +11266,9 @@
             <a:r>
               <a:rPr sz="1100" b="0">
                 <a:solidFill>
-                  <a:srgbClr val="20190F"/>
-                </a:solidFill>
-                <a:latin typeface="Arial"/>
+                  <a:srgbClr val="111111"/>
+                </a:solidFill>
+                <a:latin typeface="Verdana"/>
               </a:rPr>
               <a:t>One big open right hand, palm facing the viewer, brown skin, a farm- worker's hand (a little soil on the fingertips). Beside each finger a small picture: thumb — a simple farmer figure pointing at herself (who I am); pointer — a bed with plants and a water drum (what I have); middle — a target with a seedling in the centre (what I want); ring — three…</a:t>
             </a:r>
@@ -11289,7 +11289,7 @@
     <p:bg>
       <p:bgPr>
         <a:solidFill>
-          <a:srgbClr val="F7F2E9"/>
+          <a:srgbClr val="FFFFFF"/>
         </a:solidFill>
         <a:effectLst/>
       </p:bgPr>
@@ -11331,9 +11331,9 @@
             <a:r>
               <a:rPr sz="1000" b="0">
                 <a:solidFill>
-                  <a:srgbClr val="6B6255"/>
-                </a:solidFill>
-                <a:latin typeface="Arial"/>
+                  <a:srgbClr val="111111"/>
+                </a:solidFill>
+                <a:latin typeface="Verdana"/>
               </a:rPr>
               <a:t>A-D1-21   ·   Poster A-P05</a:t>
             </a:r>
@@ -11370,9 +11370,9 @@
             <a:r>
               <a:rPr sz="1000" b="0">
                 <a:solidFill>
-                  <a:srgbClr val="6B6255"/>
-                </a:solidFill>
-                <a:latin typeface="Arial"/>
+                  <a:srgbClr val="111111"/>
+                </a:solidFill>
+                <a:latin typeface="Verdana"/>
               </a:rPr>
               <a:t>AI Literacy</a:t>
             </a:r>
@@ -11409,9 +11409,9 @@
             <a:r>
               <a:rPr sz="3800" b="1">
                 <a:solidFill>
-                  <a:srgbClr val="1F4D2B"/>
-                </a:solidFill>
-                <a:latin typeface="Georgia"/>
+                  <a:srgbClr val="111111"/>
+                </a:solidFill>
+                <a:latin typeface="Impact"/>
               </a:rPr>
               <a:t>Closing circle</a:t>
             </a:r>
@@ -11433,7 +11433,7 @@
             <a:avLst/>
           </a:prstGeom>
           <a:solidFill>
-            <a:srgbClr val="E2D8C4"/>
+            <a:srgbClr val="D6336C"/>
           </a:solidFill>
           <a:ln>
             <a:noFill/>
@@ -11492,9 +11492,9 @@
             <a:r>
               <a:rPr sz="2400" b="0">
                 <a:solidFill>
-                  <a:srgbClr val="20190F"/>
-                </a:solidFill>
-                <a:latin typeface="Arial"/>
+                  <a:srgbClr val="111111"/>
+                </a:solidFill>
+                <a:latin typeface="Verdana"/>
               </a:rPr>
               <a:t>•  One word about today</a:t>
             </a:r>
@@ -11508,9 +11508,9 @@
             <a:r>
               <a:rPr sz="2400" b="0">
                 <a:solidFill>
-                  <a:srgbClr val="20190F"/>
-                </a:solidFill>
-                <a:latin typeface="Arial"/>
+                  <a:srgbClr val="111111"/>
+                </a:solidFill>
+                <a:latin typeface="Verdana"/>
               </a:rPr>
               <a:t>•  Take home: ask with the whole hand</a:t>
             </a:r>
@@ -11524,9 +11524,9 @@
             <a:r>
               <a:rPr sz="2400" b="0">
                 <a:solidFill>
-                  <a:srgbClr val="20190F"/>
-                </a:solidFill>
-                <a:latin typeface="Arial"/>
+                  <a:srgbClr val="111111"/>
+                </a:solidFill>
+                <a:latin typeface="Verdana"/>
               </a:rPr>
               <a:t>•  Tomorrow: check before you trust</a:t>
             </a:r>
@@ -11548,11 +11548,11 @@
             <a:avLst/>
           </a:prstGeom>
           <a:solidFill>
-            <a:srgbClr val="FBF6EC"/>
+            <a:srgbClr val="FFFFFF"/>
           </a:solidFill>
           <a:ln w="15875">
             <a:solidFill>
-              <a:srgbClr val="E2D8C4"/>
+              <a:srgbClr val="D6336C"/>
             </a:solidFill>
           </a:ln>
           <a:effectLst/>
@@ -11609,9 +11609,9 @@
             <a:r>
               <a:rPr sz="1200" b="1">
                 <a:solidFill>
-                  <a:srgbClr val="C07A1E"/>
-                </a:solidFill>
-                <a:latin typeface="Arial"/>
+                  <a:srgbClr val="1FA3C8"/>
+                </a:solidFill>
+                <a:latin typeface="Verdana"/>
               </a:rPr>
               <a:t>IMAGE · A-IMG-01 · coming</a:t>
             </a:r>
@@ -11648,9 +11648,9 @@
             <a:r>
               <a:rPr sz="1800" b="1">
                 <a:solidFill>
-                  <a:srgbClr val="1F4D2B"/>
-                </a:solidFill>
-                <a:latin typeface="Georgia"/>
+                  <a:srgbClr val="111111"/>
+                </a:solidFill>
+                <a:latin typeface="Impact"/>
               </a:rPr>
               <a:t>Learning together under a tree</a:t>
             </a:r>
@@ -11687,9 +11687,9 @@
             <a:r>
               <a:rPr sz="1100" b="0">
                 <a:solidFill>
-                  <a:srgbClr val="20190F"/>
-                </a:solidFill>
-                <a:latin typeface="Arial"/>
+                  <a:srgbClr val="111111"/>
+                </a:solidFill>
+                <a:latin typeface="Verdana"/>
               </a:rPr>
               <a:t>Landscape 16:9. A group of five learners on plastic chairs under a big shade tree near a small community garden: a gogo, an older man in a hat, two young women, a young man. One phone is shared between the gogo and a young woman; the young woman points at the screen, the gogo laughs. The others lean in. A poster on a fence behind (plain shapes, no text).…</a:t>
             </a:r>
@@ -11710,7 +11710,7 @@
     <p:bg>
       <p:bgPr>
         <a:solidFill>
-          <a:srgbClr val="1F4D2B"/>
+          <a:srgbClr val="1B1F3B"/>
         </a:solidFill>
         <a:effectLst/>
       </p:bgPr>
@@ -11752,9 +11752,9 @@
             <a:r>
               <a:rPr sz="1000" b="0">
                 <a:solidFill>
-                  <a:srgbClr val="A8D88A"/>
-                </a:solidFill>
-                <a:latin typeface="Arial"/>
+                  <a:srgbClr val="F7C948"/>
+                </a:solidFill>
+                <a:latin typeface="Verdana"/>
               </a:rPr>
               <a:t>A-D1-03   ·   Poster A-P02</a:t>
             </a:r>
@@ -11791,9 +11791,9 @@
             <a:r>
               <a:rPr sz="1000" b="0">
                 <a:solidFill>
-                  <a:srgbClr val="A8D88A"/>
-                </a:solidFill>
-                <a:latin typeface="Arial"/>
+                  <a:srgbClr val="F7C948"/>
+                </a:solidFill>
+                <a:latin typeface="Verdana"/>
               </a:rPr>
               <a:t>AI Literacy</a:t>
             </a:r>
@@ -11830,9 +11830,9 @@
             <a:r>
               <a:rPr sz="4800" b="1">
                 <a:solidFill>
-                  <a:srgbClr val="F7F2E9"/>
-                </a:solidFill>
-                <a:latin typeface="Georgia"/>
+                  <a:srgbClr val="F7C948"/>
+                </a:solidFill>
+                <a:latin typeface="Impact"/>
               </a:rPr>
               <a:t>What is AI?</a:t>
             </a:r>
@@ -11854,7 +11854,7 @@
             <a:avLst/>
           </a:prstGeom>
           <a:solidFill>
-            <a:srgbClr val="C07A1E"/>
+            <a:srgbClr val="1FA3C8"/>
           </a:solidFill>
           <a:ln>
             <a:noFill/>
@@ -11913,9 +11913,9 @@
             <a:r>
               <a:rPr sz="2400" b="0">
                 <a:solidFill>
-                  <a:srgbClr val="A8D88A"/>
-                </a:solidFill>
-                <a:latin typeface="Arial"/>
+                  <a:srgbClr val="F7C948"/>
+                </a:solidFill>
+                <a:latin typeface="Verdana"/>
               </a:rPr>
               <a:t>What is AI?</a:t>
             </a:r>
@@ -11929,9 +11929,9 @@
             <a:r>
               <a:rPr sz="2400" b="0">
                 <a:solidFill>
-                  <a:srgbClr val="A8D88A"/>
-                </a:solidFill>
-                <a:latin typeface="Arial"/>
+                  <a:srgbClr val="F7C948"/>
+                </a:solidFill>
+                <a:latin typeface="Verdana"/>
               </a:rPr>
               <a:t>Let's play first</a:t>
             </a:r>
@@ -11953,11 +11953,11 @@
             <a:avLst/>
           </a:prstGeom>
           <a:solidFill>
-            <a:srgbClr val="FBF6EC"/>
+            <a:srgbClr val="FFFFFF"/>
           </a:solidFill>
           <a:ln w="15875">
             <a:solidFill>
-              <a:srgbClr val="E2D8C4"/>
+              <a:srgbClr val="D6336C"/>
             </a:solidFill>
           </a:ln>
           <a:effectLst/>
@@ -12014,9 +12014,9 @@
             <a:r>
               <a:rPr sz="1200" b="1">
                 <a:solidFill>
-                  <a:srgbClr val="C07A1E"/>
-                </a:solidFill>
-                <a:latin typeface="Arial"/>
+                  <a:srgbClr val="1FA3C8"/>
+                </a:solidFill>
+                <a:latin typeface="Verdana"/>
               </a:rPr>
               <a:t>IMAGE · A-IMG-05 · coming</a:t>
             </a:r>
@@ -12053,9 +12053,9 @@
             <a:r>
               <a:rPr sz="1800" b="1">
                 <a:solidFill>
-                  <a:srgbClr val="1F4D2B"/>
-                </a:solidFill>
-                <a:latin typeface="Georgia"/>
+                  <a:srgbClr val="111111"/>
+                </a:solidFill>
+                <a:latin typeface="Impact"/>
               </a:rPr>
               <a:t>The AI desk (facilitator plays the machine)</a:t>
             </a:r>
@@ -12092,9 +12092,9 @@
             <a:r>
               <a:rPr sz="1100" b="0">
                 <a:solidFill>
-                  <a:srgbClr val="20190F"/>
-                </a:solidFill>
-                <a:latin typeface="Arial"/>
+                  <a:srgbClr val="111111"/>
+                </a:solidFill>
+                <a:latin typeface="Verdana"/>
               </a:rPr>
               <a:t>Landscape 16:9. A facilitator (woman, 30s) sits on a chair at the side of a hall wearing a large card on a string round her neck — the card shows a simple drawn phone with a question mark (a drawing, not words). She holds a small stack of cards and reads one in a deadpan, confident way. A group Reporter (young man) stands in front of her with a notebook;…</a:t>
             </a:r>
@@ -12115,7 +12115,7 @@
     <p:bg>
       <p:bgPr>
         <a:solidFill>
-          <a:srgbClr val="F7F2E9"/>
+          <a:srgbClr val="FFFFFF"/>
         </a:solidFill>
         <a:effectLst/>
       </p:bgPr>
@@ -12157,9 +12157,9 @@
             <a:r>
               <a:rPr sz="1000" b="0">
                 <a:solidFill>
-                  <a:srgbClr val="6B6255"/>
-                </a:solidFill>
-                <a:latin typeface="Arial"/>
+                  <a:srgbClr val="111111"/>
+                </a:solidFill>
+                <a:latin typeface="Verdana"/>
               </a:rPr>
               <a:t>A-D1-04   ·   Poster A-P02</a:t>
             </a:r>
@@ -12196,9 +12196,9 @@
             <a:r>
               <a:rPr sz="1000" b="0">
                 <a:solidFill>
-                  <a:srgbClr val="6B6255"/>
-                </a:solidFill>
-                <a:latin typeface="Arial"/>
+                  <a:srgbClr val="111111"/>
+                </a:solidFill>
+                <a:latin typeface="Verdana"/>
               </a:rPr>
               <a:t>AI Literacy</a:t>
             </a:r>
@@ -12220,7 +12220,7 @@
             <a:avLst/>
           </a:prstGeom>
           <a:solidFill>
-            <a:srgbClr val="C07A1E"/>
+            <a:srgbClr val="1FA3C8"/>
           </a:solidFill>
           <a:ln>
             <a:noFill/>
@@ -12279,9 +12279,9 @@
             <a:r>
               <a:rPr sz="1400" b="1">
                 <a:solidFill>
-                  <a:srgbClr val="F7F2E9"/>
-                </a:solidFill>
-                <a:latin typeface="Arial"/>
+                  <a:srgbClr val="FFFFFF"/>
+                </a:solidFill>
+                <a:latin typeface="Verdana"/>
               </a:rPr>
               <a:t>YOUR TURN</a:t>
             </a:r>
@@ -12318,9 +12318,9 @@
             <a:r>
               <a:rPr sz="3800" b="1">
                 <a:solidFill>
-                  <a:srgbClr val="1F4D2B"/>
-                </a:solidFill>
-                <a:latin typeface="Georgia"/>
+                  <a:srgbClr val="111111"/>
+                </a:solidFill>
+                <a:latin typeface="Impact"/>
               </a:rPr>
               <a:t>The Guessing Machine</a:t>
             </a:r>
@@ -12342,7 +12342,7 @@
             <a:avLst/>
           </a:prstGeom>
           <a:solidFill>
-            <a:srgbClr val="E2D8C4"/>
+            <a:srgbClr val="D6336C"/>
           </a:solidFill>
           <a:ln>
             <a:noFill/>
@@ -12401,9 +12401,9 @@
             <a:r>
               <a:rPr sz="2600" b="1">
                 <a:solidFill>
-                  <a:srgbClr val="20190F"/>
-                </a:solidFill>
-                <a:latin typeface="Arial"/>
+                  <a:srgbClr val="111111"/>
+                </a:solidFill>
+                <a:latin typeface="Verdana"/>
               </a:rPr>
               <a:t>•  Finish the sentence — shout it!</a:t>
             </a:r>
@@ -12417,9 +12417,9 @@
             <a:r>
               <a:rPr sz="2600" b="1">
                 <a:solidFill>
-                  <a:srgbClr val="20190F"/>
-                </a:solidFill>
-                <a:latin typeface="Arial"/>
+                  <a:srgbClr val="111111"/>
+                </a:solidFill>
+                <a:latin typeface="Verdana"/>
               </a:rPr>
               <a:t>•  The machine picks the most common</a:t>
             </a:r>
@@ -12433,9 +12433,9 @@
             <a:r>
               <a:rPr sz="2600" b="1">
                 <a:solidFill>
-                  <a:srgbClr val="20190F"/>
-                </a:solidFill>
-                <a:latin typeface="Arial"/>
+                  <a:srgbClr val="111111"/>
+                </a:solidFill>
+                <a:latin typeface="Verdana"/>
               </a:rPr>
               <a:t>•  Is the machine right about you?</a:t>
             </a:r>
@@ -12457,11 +12457,11 @@
             <a:avLst/>
           </a:prstGeom>
           <a:solidFill>
-            <a:srgbClr val="FBF6EC"/>
+            <a:srgbClr val="FFFFFF"/>
           </a:solidFill>
           <a:ln w="15875">
             <a:solidFill>
-              <a:srgbClr val="E2D8C4"/>
+              <a:srgbClr val="D6336C"/>
             </a:solidFill>
           </a:ln>
           <a:effectLst/>
@@ -12518,9 +12518,9 @@
             <a:r>
               <a:rPr sz="1200" b="1">
                 <a:solidFill>
-                  <a:srgbClr val="C07A1E"/>
-                </a:solidFill>
-                <a:latin typeface="Arial"/>
+                  <a:srgbClr val="1FA3C8"/>
+                </a:solidFill>
+                <a:latin typeface="Verdana"/>
               </a:rPr>
               <a:t>ANIMATION · A-ANI-01 · coming</a:t>
             </a:r>
@@ -12557,9 +12557,9 @@
             <a:r>
               <a:rPr sz="1800" b="1">
                 <a:solidFill>
-                  <a:srgbClr val="1F4D2B"/>
-                </a:solidFill>
-                <a:latin typeface="Georgia"/>
+                  <a:srgbClr val="111111"/>
+                </a:solidFill>
+                <a:latin typeface="Impact"/>
               </a:rPr>
               <a:t>The guessing machine</a:t>
             </a:r>
@@ -12596,9 +12596,9 @@
             <a:r>
               <a:rPr sz="1100" b="0">
                 <a:solidFill>
-                  <a:srgbClr val="20190F"/>
-                </a:solidFill>
-                <a:latin typeface="Arial"/>
+                  <a:srgbClr val="111111"/>
+                </a:solidFill>
+                <a:latin typeface="Verdana"/>
               </a:rPr>
               <a:t>Picture-only sentence game. 0–4 s: many small picture tiles (cups of tea, coffee mugs, water glasses, bowls of amahewu — tea cups most numerous) stream from the left into a simple phone-shaped machine. 4–8 s: a half-sentence picture appears (a sunrise + a person + a cup outline with a question mark). 8–11 s: the machine "thinks" (bubble pulses) and…</a:t>
             </a:r>
@@ -12619,7 +12619,7 @@
     <p:bg>
       <p:bgPr>
         <a:solidFill>
-          <a:srgbClr val="F7F2E9"/>
+          <a:srgbClr val="FFFFFF"/>
         </a:solidFill>
         <a:effectLst/>
       </p:bgPr>
@@ -12661,9 +12661,9 @@
             <a:r>
               <a:rPr sz="1000" b="0">
                 <a:solidFill>
-                  <a:srgbClr val="6B6255"/>
-                </a:solidFill>
-                <a:latin typeface="Arial"/>
+                  <a:srgbClr val="111111"/>
+                </a:solidFill>
+                <a:latin typeface="Verdana"/>
               </a:rPr>
               <a:t>A-D1-05   ·   Poster A-P02</a:t>
             </a:r>
@@ -12700,9 +12700,9 @@
             <a:r>
               <a:rPr sz="1000" b="0">
                 <a:solidFill>
-                  <a:srgbClr val="6B6255"/>
-                </a:solidFill>
-                <a:latin typeface="Arial"/>
+                  <a:srgbClr val="111111"/>
+                </a:solidFill>
+                <a:latin typeface="Verdana"/>
               </a:rPr>
               <a:t>AI Literacy</a:t>
             </a:r>
@@ -12739,9 +12739,9 @@
             <a:r>
               <a:rPr sz="3800" b="1">
                 <a:solidFill>
-                  <a:srgbClr val="1F4D2B"/>
-                </a:solidFill>
-                <a:latin typeface="Georgia"/>
+                  <a:srgbClr val="111111"/>
+                </a:solidFill>
+                <a:latin typeface="Impact"/>
               </a:rPr>
               <a:t>AI is a fast guesser</a:t>
             </a:r>
@@ -12763,7 +12763,7 @@
             <a:avLst/>
           </a:prstGeom>
           <a:solidFill>
-            <a:srgbClr val="E2D8C4"/>
+            <a:srgbClr val="D6336C"/>
           </a:solidFill>
           <a:ln>
             <a:noFill/>
@@ -12822,9 +12822,9 @@
             <a:r>
               <a:rPr sz="2400" b="0">
                 <a:solidFill>
-                  <a:srgbClr val="20190F"/>
-                </a:solidFill>
-                <a:latin typeface="Arial"/>
+                  <a:srgbClr val="111111"/>
+                </a:solidFill>
+                <a:latin typeface="Verdana"/>
               </a:rPr>
               <a:t>•  Learned from lots of words, pictures</a:t>
             </a:r>
@@ -12838,9 +12838,9 @@
             <a:r>
               <a:rPr sz="2400" b="0">
                 <a:solidFill>
-                  <a:srgbClr val="20190F"/>
-                </a:solidFill>
-                <a:latin typeface="Arial"/>
+                  <a:srgbClr val="111111"/>
+                </a:solidFill>
+                <a:latin typeface="Verdana"/>
               </a:rPr>
               <a:t>•  Sounds sure — even when wrong</a:t>
             </a:r>
@@ -12854,9 +12854,9 @@
             <a:r>
               <a:rPr sz="2400" b="0">
                 <a:solidFill>
-                  <a:srgbClr val="20190F"/>
-                </a:solidFill>
-                <a:latin typeface="Arial"/>
+                  <a:srgbClr val="111111"/>
+                </a:solidFill>
+                <a:latin typeface="Verdana"/>
               </a:rPr>
               <a:t>•  Knows only what you show it</a:t>
             </a:r>
@@ -12878,11 +12878,11 @@
             <a:avLst/>
           </a:prstGeom>
           <a:solidFill>
-            <a:srgbClr val="FBF6EC"/>
+            <a:srgbClr val="FFFFFF"/>
           </a:solidFill>
           <a:ln w="15875">
             <a:solidFill>
-              <a:srgbClr val="E2D8C4"/>
+              <a:srgbClr val="D6336C"/>
             </a:solidFill>
           </a:ln>
           <a:effectLst/>
@@ -12939,9 +12939,9 @@
             <a:r>
               <a:rPr sz="1200" b="1">
                 <a:solidFill>
-                  <a:srgbClr val="C07A1E"/>
-                </a:solidFill>
-                <a:latin typeface="Arial"/>
+                  <a:srgbClr val="1FA3C8"/>
+                </a:solidFill>
+                <a:latin typeface="Verdana"/>
               </a:rPr>
               <a:t>POSTER ART · A-P02-ART · coming</a:t>
             </a:r>
@@ -12978,9 +12978,9 @@
             <a:r>
               <a:rPr sz="1800" b="1">
                 <a:solidFill>
-                  <a:srgbClr val="1F4D2B"/>
-                </a:solidFill>
-                <a:latin typeface="Georgia"/>
+                  <a:srgbClr val="111111"/>
+                </a:solidFill>
+                <a:latin typeface="Impact"/>
               </a:rPr>
               <a:t>Artwork for A-P02 · AI is a guessing machine</a:t>
             </a:r>
@@ -13017,9 +13017,9 @@
             <a:r>
               <a:rPr sz="1100" b="0">
                 <a:solidFill>
-                  <a:srgbClr val="20190F"/>
-                </a:solidFill>
-                <a:latin typeface="Arial"/>
+                  <a:srgbClr val="111111"/>
+                </a:solidFill>
+                <a:latin typeface="Verdana"/>
               </a:rPr>
               <a:t>Centre: a friendly, simple machine made of a phone shape with a big thought bubble. Left side feeding into it: a tall stream of many small paper pages, books and photographs flying in (the training). Right side coming out: three speech bubbles; the top one has a big tick shape, the middle one a tick, the bottom one a cross — but all three bubbles look…</a:t>
             </a:r>
@@ -13040,7 +13040,7 @@
     <p:bg>
       <p:bgPr>
         <a:solidFill>
-          <a:srgbClr val="F7F2E9"/>
+          <a:srgbClr val="FFFFFF"/>
         </a:solidFill>
         <a:effectLst/>
       </p:bgPr>
@@ -13082,9 +13082,9 @@
             <a:r>
               <a:rPr sz="1000" b="0">
                 <a:solidFill>
-                  <a:srgbClr val="6B6255"/>
-                </a:solidFill>
-                <a:latin typeface="Arial"/>
+                  <a:srgbClr val="111111"/>
+                </a:solidFill>
+                <a:latin typeface="Verdana"/>
               </a:rPr>
               <a:t>A-D1-06   ·   Poster A-P02</a:t>
             </a:r>
@@ -13121,9 +13121,9 @@
             <a:r>
               <a:rPr sz="1000" b="0">
                 <a:solidFill>
-                  <a:srgbClr val="6B6255"/>
-                </a:solidFill>
-                <a:latin typeface="Arial"/>
+                  <a:srgbClr val="111111"/>
+                </a:solidFill>
+                <a:latin typeface="Verdana"/>
               </a:rPr>
               <a:t>AI Literacy</a:t>
             </a:r>
@@ -13145,7 +13145,7 @@
             <a:avLst/>
           </a:prstGeom>
           <a:solidFill>
-            <a:srgbClr val="C07A1E"/>
+            <a:srgbClr val="1FA3C8"/>
           </a:solidFill>
           <a:ln>
             <a:noFill/>
@@ -13204,9 +13204,9 @@
             <a:r>
               <a:rPr sz="1400" b="1">
                 <a:solidFill>
-                  <a:srgbClr val="F7F2E9"/>
-                </a:solidFill>
-                <a:latin typeface="Arial"/>
+                  <a:srgbClr val="FFFFFF"/>
+                </a:solidFill>
+                <a:latin typeface="Verdana"/>
               </a:rPr>
               <a:t>YOUR TURN</a:t>
             </a:r>
@@ -13243,9 +13243,9 @@
             <a:r>
               <a:rPr sz="3800" b="1">
                 <a:solidFill>
-                  <a:srgbClr val="1F4D2B"/>
-                </a:solidFill>
-                <a:latin typeface="Georgia"/>
+                  <a:srgbClr val="111111"/>
+                </a:solidFill>
+                <a:latin typeface="Impact"/>
               </a:rPr>
               <a:t>True or false? Stand or sit</a:t>
             </a:r>
@@ -13267,7 +13267,7 @@
             <a:avLst/>
           </a:prstGeom>
           <a:solidFill>
-            <a:srgbClr val="E2D8C4"/>
+            <a:srgbClr val="D6336C"/>
           </a:solidFill>
           <a:ln>
             <a:noFill/>
@@ -13326,9 +13326,9 @@
             <a:r>
               <a:rPr sz="3000" b="1">
                 <a:solidFill>
-                  <a:srgbClr val="20190F"/>
-                </a:solidFill>
-                <a:latin typeface="Arial"/>
+                  <a:srgbClr val="111111"/>
+                </a:solidFill>
+                <a:latin typeface="Verdana"/>
               </a:rPr>
               <a:t>•  Stand = true · Sit = false</a:t>
             </a:r>
@@ -13342,9 +13342,9 @@
             <a:r>
               <a:rPr sz="3000" b="1">
                 <a:solidFill>
-                  <a:srgbClr val="20190F"/>
-                </a:solidFill>
-                <a:latin typeface="Arial"/>
+                  <a:srgbClr val="111111"/>
+                </a:solidFill>
+                <a:latin typeface="Verdana"/>
               </a:rPr>
               <a:t>•  8 statements about AI</a:t>
             </a:r>
@@ -13366,11 +13366,11 @@
             <a:avLst/>
           </a:prstGeom>
           <a:solidFill>
-            <a:srgbClr val="FBF6EC"/>
+            <a:srgbClr val="FFFFFF"/>
           </a:solidFill>
           <a:ln w="15875">
             <a:solidFill>
-              <a:srgbClr val="E2D8C4"/>
+              <a:srgbClr val="D6336C"/>
             </a:solidFill>
           </a:ln>
           <a:effectLst/>
@@ -13427,9 +13427,9 @@
             <a:r>
               <a:rPr sz="1200" b="1">
                 <a:solidFill>
-                  <a:srgbClr val="C07A1E"/>
-                </a:solidFill>
-                <a:latin typeface="Arial"/>
+                  <a:srgbClr val="1FA3C8"/>
+                </a:solidFill>
+                <a:latin typeface="Verdana"/>
               </a:rPr>
               <a:t>POSTER ART · A-P02-ART · coming</a:t>
             </a:r>
@@ -13466,9 +13466,9 @@
             <a:r>
               <a:rPr sz="1800" b="1">
                 <a:solidFill>
-                  <a:srgbClr val="1F4D2B"/>
-                </a:solidFill>
-                <a:latin typeface="Georgia"/>
+                  <a:srgbClr val="111111"/>
+                </a:solidFill>
+                <a:latin typeface="Impact"/>
               </a:rPr>
               <a:t>Artwork for A-P02 · AI is a guessing machine</a:t>
             </a:r>
@@ -13505,9 +13505,9 @@
             <a:r>
               <a:rPr sz="1100" b="0">
                 <a:solidFill>
-                  <a:srgbClr val="20190F"/>
-                </a:solidFill>
-                <a:latin typeface="Arial"/>
+                  <a:srgbClr val="111111"/>
+                </a:solidFill>
+                <a:latin typeface="Verdana"/>
               </a:rPr>
               <a:t>Centre: a friendly, simple machine made of a phone shape with a big thought bubble. Left side feeding into it: a tall stream of many small paper pages, books and photographs flying in (the training). Right side coming out: three speech bubbles; the top one has a big tick shape, the middle one a tick, the bottom one a cross — but all three bubbles look…</a:t>
             </a:r>
@@ -13528,7 +13528,7 @@
     <p:bg>
       <p:bgPr>
         <a:solidFill>
-          <a:srgbClr val="F7F2E9"/>
+          <a:srgbClr val="FFFFFF"/>
         </a:solidFill>
         <a:effectLst/>
       </p:bgPr>
@@ -13570,9 +13570,9 @@
             <a:r>
               <a:rPr sz="1000" b="0">
                 <a:solidFill>
-                  <a:srgbClr val="6B6255"/>
-                </a:solidFill>
-                <a:latin typeface="Arial"/>
+                  <a:srgbClr val="111111"/>
+                </a:solidFill>
+                <a:latin typeface="Verdana"/>
               </a:rPr>
               <a:t>A-D1-07   ·   Poster A-P03</a:t>
             </a:r>
@@ -13609,9 +13609,9 @@
             <a:r>
               <a:rPr sz="1000" b="0">
                 <a:solidFill>
-                  <a:srgbClr val="6B6255"/>
-                </a:solidFill>
-                <a:latin typeface="Arial"/>
+                  <a:srgbClr val="111111"/>
+                </a:solidFill>
+                <a:latin typeface="Verdana"/>
               </a:rPr>
               <a:t>AI Literacy</a:t>
             </a:r>
@@ -13648,9 +13648,9 @@
             <a:r>
               <a:rPr sz="3800" b="1">
                 <a:solidFill>
-                  <a:srgbClr val="1F4D2B"/>
-                </a:solidFill>
-                <a:latin typeface="Georgia"/>
+                  <a:srgbClr val="111111"/>
+                </a:solidFill>
+                <a:latin typeface="Impact"/>
               </a:rPr>
               <a:t>AI is already here</a:t>
             </a:r>
@@ -13672,7 +13672,7 @@
             <a:avLst/>
           </a:prstGeom>
           <a:solidFill>
-            <a:srgbClr val="E2D8C4"/>
+            <a:srgbClr val="D6336C"/>
           </a:solidFill>
           <a:ln>
             <a:noFill/>
@@ -13731,9 +13731,9 @@
             <a:r>
               <a:rPr sz="2400" b="0">
                 <a:solidFill>
-                  <a:srgbClr val="20190F"/>
-                </a:solidFill>
-                <a:latin typeface="Arial"/>
+                  <a:srgbClr val="111111"/>
+                </a:solidFill>
+                <a:latin typeface="Verdana"/>
               </a:rPr>
               <a:t>•  Keyboard, mic, camera, chat</a:t>
             </a:r>
@@ -13747,9 +13747,9 @@
             <a:r>
               <a:rPr sz="2400" b="0">
                 <a:solidFill>
-                  <a:srgbClr val="20190F"/>
-                </a:solidFill>
-                <a:latin typeface="Arial"/>
+                  <a:srgbClr val="111111"/>
+                </a:solidFill>
+                <a:latin typeface="Verdana"/>
               </a:rPr>
               <a:t>•  Translate, videos, spam warnings</a:t>
             </a:r>
@@ -13763,9 +13763,9 @@
             <a:r>
               <a:rPr sz="2400" b="0">
                 <a:solidFill>
-                  <a:srgbClr val="20190F"/>
-                </a:solidFill>
-                <a:latin typeface="Arial"/>
+                  <a:srgbClr val="111111"/>
+                </a:solidFill>
+                <a:latin typeface="Verdana"/>
               </a:rPr>
               <a:t>•  Garden app helper (Lima)</a:t>
             </a:r>
@@ -13787,11 +13787,11 @@
             <a:avLst/>
           </a:prstGeom>
           <a:solidFill>
-            <a:srgbClr val="FBF6EC"/>
+            <a:srgbClr val="FFFFFF"/>
           </a:solidFill>
           <a:ln w="15875">
             <a:solidFill>
-              <a:srgbClr val="E2D8C4"/>
+              <a:srgbClr val="D6336C"/>
             </a:solidFill>
           </a:ln>
           <a:effectLst/>
@@ -13848,9 +13848,9 @@
             <a:r>
               <a:rPr sz="1200" b="1">
                 <a:solidFill>
-                  <a:srgbClr val="C07A1E"/>
-                </a:solidFill>
-                <a:latin typeface="Arial"/>
+                  <a:srgbClr val="1FA3C8"/>
+                </a:solidFill>
+                <a:latin typeface="Verdana"/>
               </a:rPr>
               <a:t>POSTER ART · A-P03-ART · coming</a:t>
             </a:r>
@@ -13887,9 +13887,9 @@
             <a:r>
               <a:rPr sz="1800" b="1">
                 <a:solidFill>
-                  <a:srgbClr val="1F4D2B"/>
-                </a:solidFill>
-                <a:latin typeface="Georgia"/>
+                  <a:srgbClr val="111111"/>
+                </a:solidFill>
+                <a:latin typeface="Impact"/>
               </a:rPr>
               <a:t>Artwork for A-P03 · Where you already meet AI</a:t>
             </a:r>
@@ -13926,9 +13926,9 @@
             <a:r>
               <a:rPr sz="1100" b="0">
                 <a:solidFill>
-                  <a:srgbClr val="20190F"/>
-                </a:solidFill>
-                <a:latin typeface="Arial"/>
+                  <a:srgbClr val="111111"/>
+                </a:solidFill>
+                <a:latin typeface="Verdana"/>
               </a:rPr>
               <a:t>One large phone in the centre, drawn slightly tilted, held in a youth's hand. Around it, six icon "islands" joined to the phone by dotted lines: a keyboard with three suggestion bubbles above it; a microphone; a chat bubble with a small round ring icon; a camera frame over a leaf; two overlapping speech bubbles (translation); a small seedling in a circle…</a:t>
             </a:r>
@@ -13949,7 +13949,7 @@
     <p:bg>
       <p:bgPr>
         <a:solidFill>
-          <a:srgbClr val="1F4D2B"/>
+          <a:srgbClr val="1B1F3B"/>
         </a:solidFill>
         <a:effectLst/>
       </p:bgPr>
@@ -13991,9 +13991,9 @@
             <a:r>
               <a:rPr sz="1000" b="0">
                 <a:solidFill>
-                  <a:srgbClr val="A8D88A"/>
-                </a:solidFill>
-                <a:latin typeface="Arial"/>
+                  <a:srgbClr val="F7C948"/>
+                </a:solidFill>
+                <a:latin typeface="Verdana"/>
               </a:rPr>
               <a:t>A-D1-08   ·   Poster A-P04</a:t>
             </a:r>
@@ -14030,9 +14030,9 @@
             <a:r>
               <a:rPr sz="1000" b="0">
                 <a:solidFill>
-                  <a:srgbClr val="A8D88A"/>
-                </a:solidFill>
-                <a:latin typeface="Arial"/>
+                  <a:srgbClr val="F7C948"/>
+                </a:solidFill>
+                <a:latin typeface="Verdana"/>
               </a:rPr>
               <a:t>AI Literacy</a:t>
             </a:r>
@@ -14069,9 +14069,9 @@
             <a:r>
               <a:rPr sz="4800" b="1">
                 <a:solidFill>
-                  <a:srgbClr val="F7F2E9"/>
-                </a:solidFill>
-                <a:latin typeface="Georgia"/>
+                  <a:srgbClr val="F7C948"/>
+                </a:solidFill>
+                <a:latin typeface="Impact"/>
               </a:rPr>
               <a:t>Ask well</a:t>
             </a:r>
@@ -14093,7 +14093,7 @@
             <a:avLst/>
           </a:prstGeom>
           <a:solidFill>
-            <a:srgbClr val="C07A1E"/>
+            <a:srgbClr val="1FA3C8"/>
           </a:solidFill>
           <a:ln>
             <a:noFill/>
@@ -14152,9 +14152,9 @@
             <a:r>
               <a:rPr sz="2400" b="0">
                 <a:solidFill>
-                  <a:srgbClr val="A8D88A"/>
-                </a:solidFill>
-                <a:latin typeface="Arial"/>
+                  <a:srgbClr val="F7C948"/>
+                </a:solidFill>
+                <a:latin typeface="Verdana"/>
               </a:rPr>
               <a:t>Phone ready</a:t>
             </a:r>
@@ -14168,9 +14168,9 @@
             <a:r>
               <a:rPr sz="2400" b="0">
                 <a:solidFill>
-                  <a:srgbClr val="A8D88A"/>
-                </a:solidFill>
-                <a:latin typeface="Arial"/>
+                  <a:srgbClr val="F7C948"/>
+                </a:solidFill>
+                <a:latin typeface="Verdana"/>
               </a:rPr>
               <a:t>Then the Question Hand</a:t>
             </a:r>
@@ -14192,11 +14192,11 @@
             <a:avLst/>
           </a:prstGeom>
           <a:solidFill>
-            <a:srgbClr val="FBF6EC"/>
+            <a:srgbClr val="FFFFFF"/>
           </a:solidFill>
           <a:ln w="15875">
             <a:solidFill>
-              <a:srgbClr val="E2D8C4"/>
+              <a:srgbClr val="D6336C"/>
             </a:solidFill>
           </a:ln>
           <a:effectLst/>
@@ -14253,9 +14253,9 @@
             <a:r>
               <a:rPr sz="1200" b="1">
                 <a:solidFill>
-                  <a:srgbClr val="C07A1E"/>
-                </a:solidFill>
-                <a:latin typeface="Arial"/>
+                  <a:srgbClr val="1FA3C8"/>
+                </a:solidFill>
+                <a:latin typeface="Verdana"/>
               </a:rPr>
               <a:t>POSTER ART · A-P04-ART · coming</a:t>
             </a:r>
@@ -14292,9 +14292,9 @@
             <a:r>
               <a:rPr sz="1800" b="1">
                 <a:solidFill>
-                  <a:srgbClr val="1F4D2B"/>
-                </a:solidFill>
-                <a:latin typeface="Georgia"/>
+                  <a:srgbClr val="111111"/>
+                </a:solidFill>
+                <a:latin typeface="Impact"/>
               </a:rPr>
               <a:t>Artwork for A-P04 · Save your data</a:t>
             </a:r>
@@ -14331,9 +14331,9 @@
             <a:r>
               <a:rPr sz="1100" b="0">
                 <a:solidFill>
-                  <a:srgbClr val="20190F"/>
-                </a:solidFill>
-                <a:latin typeface="Arial"/>
+                  <a:srgbClr val="111111"/>
+                </a:solidFill>
+                <a:latin typeface="Verdana"/>
               </a:rPr>
               <a:t>A phone drawn as a clay water pot (a data "pot") with a small tap at the bottom; a few drops fall from it. Around it: ① a photo/video icon with a pause symbol (auto-download off), ② a small photo next to a big photo, the small one ticked (standard quality), ③ a gauge/dial turned to low (data saver), ④ a Wi-Fi fan-shape over a download arrow (updates on…</a:t>
             </a:r>
@@ -14354,7 +14354,7 @@
     <p:bg>
       <p:bgPr>
         <a:solidFill>
-          <a:srgbClr val="F7F2E9"/>
+          <a:srgbClr val="FFFFFF"/>
         </a:solidFill>
         <a:effectLst/>
       </p:bgPr>
@@ -14396,9 +14396,9 @@
             <a:r>
               <a:rPr sz="1000" b="0">
                 <a:solidFill>
-                  <a:srgbClr val="6B6255"/>
-                </a:solidFill>
-                <a:latin typeface="Arial"/>
+                  <a:srgbClr val="111111"/>
+                </a:solidFill>
+                <a:latin typeface="Verdana"/>
               </a:rPr>
               <a:t>A-D1-09   ·   Poster A-P04</a:t>
             </a:r>
@@ -14435,9 +14435,9 @@
             <a:r>
               <a:rPr sz="1000" b="0">
                 <a:solidFill>
-                  <a:srgbClr val="6B6255"/>
-                </a:solidFill>
-                <a:latin typeface="Arial"/>
+                  <a:srgbClr val="111111"/>
+                </a:solidFill>
+                <a:latin typeface="Verdana"/>
               </a:rPr>
               <a:t>AI Literacy</a:t>
             </a:r>
@@ -14474,9 +14474,9 @@
             <a:r>
               <a:rPr sz="3800" b="1">
                 <a:solidFill>
-                  <a:srgbClr val="1F4D2B"/>
-                </a:solidFill>
-                <a:latin typeface="Georgia"/>
+                  <a:srgbClr val="111111"/>
+                </a:solidFill>
+                <a:latin typeface="Impact"/>
               </a:rPr>
               <a:t>Make your data last</a:t>
             </a:r>
@@ -14498,7 +14498,7 @@
             <a:avLst/>
           </a:prstGeom>
           <a:solidFill>
-            <a:srgbClr val="E2D8C4"/>
+            <a:srgbClr val="D6336C"/>
           </a:solidFill>
           <a:ln>
             <a:noFill/>
@@ -14557,9 +14557,9 @@
             <a:r>
               <a:rPr sz="2400" b="0">
                 <a:solidFill>
-                  <a:srgbClr val="20190F"/>
-                </a:solidFill>
-                <a:latin typeface="Arial"/>
+                  <a:srgbClr val="111111"/>
+                </a:solidFill>
+                <a:latin typeface="Verdana"/>
               </a:rPr>
               <a:t>•  WhatsApp auto-download: off</a:t>
             </a:r>
@@ -14573,9 +14573,9 @@
             <a:r>
               <a:rPr sz="2400" b="0">
                 <a:solidFill>
-                  <a:srgbClr val="20190F"/>
-                </a:solidFill>
-                <a:latin typeface="Arial"/>
+                  <a:srgbClr val="111111"/>
+                </a:solidFill>
+                <a:latin typeface="Verdana"/>
               </a:rPr>
               <a:t>•  Photos: standard · Data saver: on</a:t>
             </a:r>
@@ -14589,9 +14589,9 @@
             <a:r>
               <a:rPr sz="2400" b="0">
                 <a:solidFill>
-                  <a:srgbClr val="20190F"/>
-                </a:solidFill>
-                <a:latin typeface="Arial"/>
+                  <a:srgbClr val="111111"/>
+                </a:solidFill>
+                <a:latin typeface="Verdana"/>
               </a:rPr>
               <a:t>•  Updates on Wi-Fi only</a:t>
             </a:r>
@@ -14613,11 +14613,11 @@
             <a:avLst/>
           </a:prstGeom>
           <a:solidFill>
-            <a:srgbClr val="FBF6EC"/>
+            <a:srgbClr val="FFFFFF"/>
           </a:solidFill>
           <a:ln w="15875">
             <a:solidFill>
-              <a:srgbClr val="E2D8C4"/>
+              <a:srgbClr val="D6336C"/>
             </a:solidFill>
           </a:ln>
           <a:effectLst/>
@@ -14674,9 +14674,9 @@
             <a:r>
               <a:rPr sz="1200" b="1">
                 <a:solidFill>
-                  <a:srgbClr val="C07A1E"/>
-                </a:solidFill>
-                <a:latin typeface="Arial"/>
+                  <a:srgbClr val="1FA3C8"/>
+                </a:solidFill>
+                <a:latin typeface="Verdana"/>
               </a:rPr>
               <a:t>POSTER ART · A-P04-ART · coming</a:t>
             </a:r>
@@ -14713,9 +14713,9 @@
             <a:r>
               <a:rPr sz="1800" b="1">
                 <a:solidFill>
-                  <a:srgbClr val="1F4D2B"/>
-                </a:solidFill>
-                <a:latin typeface="Georgia"/>
+                  <a:srgbClr val="111111"/>
+                </a:solidFill>
+                <a:latin typeface="Impact"/>
               </a:rPr>
               <a:t>Artwork for A-P04 · Save your data</a:t>
             </a:r>
@@ -14752,9 +14752,9 @@
             <a:r>
               <a:rPr sz="1100" b="0">
                 <a:solidFill>
-                  <a:srgbClr val="20190F"/>
-                </a:solidFill>
-                <a:latin typeface="Arial"/>
+                  <a:srgbClr val="111111"/>
+                </a:solidFill>
+                <a:latin typeface="Verdana"/>
               </a:rPr>
               <a:t>A phone drawn as a clay water pot (a data "pot") with a small tap at the bottom; a few drops fall from it. Around it: ① a photo/video icon with a pause symbol (auto-download off), ② a small photo next to a big photo, the small one ticked (standard quality), ③ a gauge/dial turned to low (data saver), ④ a Wi-Fi fan-shape over a download arrow (updates on…</a:t>
             </a:r>

</xml_diff>